<commit_message>
Add GitHub repository link to presentation slides (Cover, Live Demo, and Q&A)
</commit_message>
<xml_diff>
--- a/A4_Presentation_Rahime_Nacak.pptx
+++ b/A4_Presentation_Rahime_Nacak.pptx
@@ -5,26 +5,26 @@
     <p:sldMasterId id="2147483648" r:id="rId1"/>
   </p:sldMasterIdLst>
   <p:sldIdLst>
-    <p:sldId id="256" r:id="rId2"/>
-    <p:sldId id="257" r:id="rId3"/>
-    <p:sldId id="258" r:id="rId4"/>
-    <p:sldId id="259" r:id="rId5"/>
-    <p:sldId id="260" r:id="rId6"/>
-    <p:sldId id="261" r:id="rId7"/>
-    <p:sldId id="262" r:id="rId8"/>
-    <p:sldId id="263" r:id="rId9"/>
-    <p:sldId id="264" r:id="rId10"/>
-    <p:sldId id="265" r:id="rId11"/>
-    <p:sldId id="266" r:id="rId12"/>
-    <p:sldId id="267" r:id="rId13"/>
-    <p:sldId id="268" r:id="rId14"/>
-    <p:sldId id="269" r:id="rId15"/>
-    <p:sldId id="270" r:id="rId16"/>
-    <p:sldId id="271" r:id="rId17"/>
-    <p:sldId id="272" r:id="rId18"/>
-    <p:sldId id="273" r:id="rId19"/>
+    <p:sldId id="256" r:id="rId7"/>
+    <p:sldId id="257" r:id="rId8"/>
+    <p:sldId id="258" r:id="rId9"/>
+    <p:sldId id="259" r:id="rId10"/>
+    <p:sldId id="260" r:id="rId11"/>
+    <p:sldId id="261" r:id="rId12"/>
+    <p:sldId id="262" r:id="rId13"/>
+    <p:sldId id="263" r:id="rId14"/>
+    <p:sldId id="264" r:id="rId15"/>
+    <p:sldId id="265" r:id="rId16"/>
+    <p:sldId id="266" r:id="rId17"/>
+    <p:sldId id="267" r:id="rId18"/>
+    <p:sldId id="268" r:id="rId19"/>
+    <p:sldId id="269" r:id="rId20"/>
+    <p:sldId id="270" r:id="rId21"/>
+    <p:sldId id="271" r:id="rId22"/>
+    <p:sldId id="272" r:id="rId23"/>
+    <p:sldId id="273" r:id="rId24"/>
   </p:sldIdLst>
-  <p:sldSz cx="12188825" cy="6858000"/>
+  <p:sldSz cx="12188952" cy="6858000" type="screen4x3"/>
   <p:notesSz cx="6858000" cy="9144000"/>
   <p:defaultTextStyle>
     <a:defPPr>
@@ -121,22 +121,6 @@
       </a:defRPr>
     </a:lvl9pPr>
   </p:defaultTextStyle>
-  <p:extLst>
-    <p:ext uri="{EFAFB233-063F-42B5-8137-9DF3F51BA10A}">
-      <p15:sldGuideLst xmlns:p15="http://schemas.microsoft.com/office/powerpoint/2012/main">
-        <p15:guide id="1" orient="horz" pos="2160">
-          <p15:clr>
-            <a:srgbClr val="A4A3A4"/>
-          </p15:clr>
-        </p15:guide>
-        <p15:guide id="2" pos="2880">
-          <p15:clr>
-            <a:srgbClr val="A4A3A4"/>
-          </p15:clr>
-        </p15:guide>
-      </p15:sldGuideLst>
-    </p:ext>
-  </p:extLst>
 </p:presentation>
 </file>
 
@@ -178,9 +162,10 @@
           <a:lstStyle/>
           <a:p>
             <a:r>
-              <a:rPr lang="en-US"/>
+              <a:rPr lang="en-US" smtClean="0"/>
               <a:t>Click to edit Master title style</a:t>
             </a:r>
+            <a:endParaRPr lang="en-US"/>
           </a:p>
         </p:txBody>
       </p:sp>
@@ -296,9 +281,10 @@
           </a:lstStyle>
           <a:p>
             <a:r>
-              <a:rPr lang="en-US"/>
+              <a:rPr lang="en-US" smtClean="0"/>
               <a:t>Click to edit Master subtitle style</a:t>
             </a:r>
+            <a:endParaRPr lang="en-US"/>
           </a:p>
         </p:txBody>
       </p:sp>
@@ -319,7 +305,7 @@
           <a:p>
             <a:fld id="{5BCAD085-E8A6-8845-BD4E-CB4CCA059FC4}" type="datetimeFigureOut">
               <a:rPr lang="en-US" smtClean="0"/>
-              <a:t>10/13/26</a:t>
+              <a:t>1/27/13</a:t>
             </a:fld>
             <a:endParaRPr lang="en-US"/>
           </a:p>
@@ -413,9 +399,10 @@
           <a:lstStyle/>
           <a:p>
             <a:r>
-              <a:rPr lang="en-US"/>
+              <a:rPr lang="en-US" smtClean="0"/>
               <a:t>Click to edit Master title style</a:t>
             </a:r>
+            <a:endParaRPr lang="en-US"/>
           </a:p>
         </p:txBody>
       </p:sp>
@@ -436,37 +423,38 @@
           <a:p>
             <a:pPr lvl="0"/>
             <a:r>
-              <a:rPr lang="en-US"/>
+              <a:rPr lang="en-US" smtClean="0"/>
               <a:t>Click to edit Master text styles</a:t>
             </a:r>
           </a:p>
           <a:p>
             <a:pPr lvl="1"/>
             <a:r>
-              <a:rPr lang="en-US"/>
+              <a:rPr lang="en-US" smtClean="0"/>
               <a:t>Second level</a:t>
             </a:r>
           </a:p>
           <a:p>
             <a:pPr lvl="2"/>
             <a:r>
-              <a:rPr lang="en-US"/>
+              <a:rPr lang="en-US" smtClean="0"/>
               <a:t>Third level</a:t>
             </a:r>
           </a:p>
           <a:p>
             <a:pPr lvl="3"/>
             <a:r>
-              <a:rPr lang="en-US"/>
+              <a:rPr lang="en-US" smtClean="0"/>
               <a:t>Fourth level</a:t>
             </a:r>
           </a:p>
           <a:p>
             <a:pPr lvl="4"/>
             <a:r>
-              <a:rPr lang="en-US"/>
+              <a:rPr lang="en-US" smtClean="0"/>
               <a:t>Fifth level</a:t>
             </a:r>
+            <a:endParaRPr lang="en-US"/>
           </a:p>
         </p:txBody>
       </p:sp>
@@ -487,7 +475,7 @@
           <a:p>
             <a:fld id="{5BCAD085-E8A6-8845-BD4E-CB4CCA059FC4}" type="datetimeFigureOut">
               <a:rPr lang="en-US" smtClean="0"/>
-              <a:t>10/13/26</a:t>
+              <a:t>1/27/13</a:t>
             </a:fld>
             <a:endParaRPr lang="en-US"/>
           </a:p>
@@ -586,9 +574,10 @@
           <a:lstStyle/>
           <a:p>
             <a:r>
-              <a:rPr lang="en-US"/>
+              <a:rPr lang="en-US" smtClean="0"/>
               <a:t>Click to edit Master title style</a:t>
             </a:r>
+            <a:endParaRPr lang="en-US"/>
           </a:p>
         </p:txBody>
       </p:sp>
@@ -614,37 +603,38 @@
           <a:p>
             <a:pPr lvl="0"/>
             <a:r>
-              <a:rPr lang="en-US"/>
+              <a:rPr lang="en-US" smtClean="0"/>
               <a:t>Click to edit Master text styles</a:t>
             </a:r>
           </a:p>
           <a:p>
             <a:pPr lvl="1"/>
             <a:r>
-              <a:rPr lang="en-US"/>
+              <a:rPr lang="en-US" smtClean="0"/>
               <a:t>Second level</a:t>
             </a:r>
           </a:p>
           <a:p>
             <a:pPr lvl="2"/>
             <a:r>
-              <a:rPr lang="en-US"/>
+              <a:rPr lang="en-US" smtClean="0"/>
               <a:t>Third level</a:t>
             </a:r>
           </a:p>
           <a:p>
             <a:pPr lvl="3"/>
             <a:r>
-              <a:rPr lang="en-US"/>
+              <a:rPr lang="en-US" smtClean="0"/>
               <a:t>Fourth level</a:t>
             </a:r>
           </a:p>
           <a:p>
             <a:pPr lvl="4"/>
             <a:r>
-              <a:rPr lang="en-US"/>
+              <a:rPr lang="en-US" smtClean="0"/>
               <a:t>Fifth level</a:t>
             </a:r>
+            <a:endParaRPr lang="en-US"/>
           </a:p>
         </p:txBody>
       </p:sp>
@@ -665,7 +655,7 @@
           <a:p>
             <a:fld id="{5BCAD085-E8A6-8845-BD4E-CB4CCA059FC4}" type="datetimeFigureOut">
               <a:rPr lang="en-US" smtClean="0"/>
-              <a:t>10/13/26</a:t>
+              <a:t>1/27/13</a:t>
             </a:fld>
             <a:endParaRPr lang="en-US"/>
           </a:p>
@@ -759,9 +749,10 @@
           <a:lstStyle/>
           <a:p>
             <a:r>
-              <a:rPr lang="en-US"/>
+              <a:rPr lang="en-US" smtClean="0"/>
               <a:t>Click to edit Master title style</a:t>
             </a:r>
+            <a:endParaRPr lang="en-US"/>
           </a:p>
         </p:txBody>
       </p:sp>
@@ -782,37 +773,38 @@
           <a:p>
             <a:pPr lvl="0"/>
             <a:r>
-              <a:rPr lang="en-US"/>
+              <a:rPr lang="en-US" smtClean="0"/>
               <a:t>Click to edit Master text styles</a:t>
             </a:r>
           </a:p>
           <a:p>
             <a:pPr lvl="1"/>
             <a:r>
-              <a:rPr lang="en-US"/>
+              <a:rPr lang="en-US" smtClean="0"/>
               <a:t>Second level</a:t>
             </a:r>
           </a:p>
           <a:p>
             <a:pPr lvl="2"/>
             <a:r>
-              <a:rPr lang="en-US"/>
+              <a:rPr lang="en-US" smtClean="0"/>
               <a:t>Third level</a:t>
             </a:r>
           </a:p>
           <a:p>
             <a:pPr lvl="3"/>
             <a:r>
-              <a:rPr lang="en-US"/>
+              <a:rPr lang="en-US" smtClean="0"/>
               <a:t>Fourth level</a:t>
             </a:r>
           </a:p>
           <a:p>
             <a:pPr lvl="4"/>
             <a:r>
-              <a:rPr lang="en-US"/>
+              <a:rPr lang="en-US" smtClean="0"/>
               <a:t>Fifth level</a:t>
             </a:r>
+            <a:endParaRPr lang="en-US"/>
           </a:p>
         </p:txBody>
       </p:sp>
@@ -833,7 +825,7 @@
           <a:p>
             <a:fld id="{5BCAD085-E8A6-8845-BD4E-CB4CCA059FC4}" type="datetimeFigureOut">
               <a:rPr lang="en-US" smtClean="0"/>
-              <a:t>10/13/26</a:t>
+              <a:t>1/27/13</a:t>
             </a:fld>
             <a:endParaRPr lang="en-US"/>
           </a:p>
@@ -936,9 +928,10 @@
           </a:lstStyle>
           <a:p>
             <a:r>
-              <a:rPr lang="en-US"/>
+              <a:rPr lang="en-US" smtClean="0"/>
               <a:t>Click to edit Master title style</a:t>
             </a:r>
+            <a:endParaRPr lang="en-US"/>
           </a:p>
         </p:txBody>
       </p:sp>
@@ -1055,7 +1048,7 @@
           <a:p>
             <a:pPr lvl="0"/>
             <a:r>
-              <a:rPr lang="en-US"/>
+              <a:rPr lang="en-US" smtClean="0"/>
               <a:t>Click to edit Master text styles</a:t>
             </a:r>
           </a:p>
@@ -1078,7 +1071,7 @@
           <a:p>
             <a:fld id="{5BCAD085-E8A6-8845-BD4E-CB4CCA059FC4}" type="datetimeFigureOut">
               <a:rPr lang="en-US" smtClean="0"/>
-              <a:t>10/13/26</a:t>
+              <a:t>1/27/13</a:t>
             </a:fld>
             <a:endParaRPr lang="en-US"/>
           </a:p>
@@ -1172,9 +1165,10 @@
           <a:lstStyle/>
           <a:p>
             <a:r>
-              <a:rPr lang="en-US"/>
+              <a:rPr lang="en-US" smtClean="0"/>
               <a:t>Click to edit Master title style</a:t>
             </a:r>
+            <a:endParaRPr lang="en-US"/>
           </a:p>
         </p:txBody>
       </p:sp>
@@ -1228,37 +1222,38 @@
           <a:p>
             <a:pPr lvl="0"/>
             <a:r>
-              <a:rPr lang="en-US"/>
+              <a:rPr lang="en-US" smtClean="0"/>
               <a:t>Click to edit Master text styles</a:t>
             </a:r>
           </a:p>
           <a:p>
             <a:pPr lvl="1"/>
             <a:r>
-              <a:rPr lang="en-US"/>
+              <a:rPr lang="en-US" smtClean="0"/>
               <a:t>Second level</a:t>
             </a:r>
           </a:p>
           <a:p>
             <a:pPr lvl="2"/>
             <a:r>
-              <a:rPr lang="en-US"/>
+              <a:rPr lang="en-US" smtClean="0"/>
               <a:t>Third level</a:t>
             </a:r>
           </a:p>
           <a:p>
             <a:pPr lvl="3"/>
             <a:r>
-              <a:rPr lang="en-US"/>
+              <a:rPr lang="en-US" smtClean="0"/>
               <a:t>Fourth level</a:t>
             </a:r>
           </a:p>
           <a:p>
             <a:pPr lvl="4"/>
             <a:r>
-              <a:rPr lang="en-US"/>
+              <a:rPr lang="en-US" smtClean="0"/>
               <a:t>Fifth level</a:t>
             </a:r>
+            <a:endParaRPr lang="en-US"/>
           </a:p>
         </p:txBody>
       </p:sp>
@@ -1312,37 +1307,38 @@
           <a:p>
             <a:pPr lvl="0"/>
             <a:r>
-              <a:rPr lang="en-US"/>
+              <a:rPr lang="en-US" smtClean="0"/>
               <a:t>Click to edit Master text styles</a:t>
             </a:r>
           </a:p>
           <a:p>
             <a:pPr lvl="1"/>
             <a:r>
-              <a:rPr lang="en-US"/>
+              <a:rPr lang="en-US" smtClean="0"/>
               <a:t>Second level</a:t>
             </a:r>
           </a:p>
           <a:p>
             <a:pPr lvl="2"/>
             <a:r>
-              <a:rPr lang="en-US"/>
+              <a:rPr lang="en-US" smtClean="0"/>
               <a:t>Third level</a:t>
             </a:r>
           </a:p>
           <a:p>
             <a:pPr lvl="3"/>
             <a:r>
-              <a:rPr lang="en-US"/>
+              <a:rPr lang="en-US" smtClean="0"/>
               <a:t>Fourth level</a:t>
             </a:r>
           </a:p>
           <a:p>
             <a:pPr lvl="4"/>
             <a:r>
-              <a:rPr lang="en-US"/>
+              <a:rPr lang="en-US" smtClean="0"/>
               <a:t>Fifth level</a:t>
             </a:r>
+            <a:endParaRPr lang="en-US"/>
           </a:p>
         </p:txBody>
       </p:sp>
@@ -1363,7 +1359,7 @@
           <a:p>
             <a:fld id="{5BCAD085-E8A6-8845-BD4E-CB4CCA059FC4}" type="datetimeFigureOut">
               <a:rPr lang="en-US" smtClean="0"/>
-              <a:t>10/13/26</a:t>
+              <a:t>1/27/13</a:t>
             </a:fld>
             <a:endParaRPr lang="en-US"/>
           </a:p>
@@ -1461,9 +1457,10 @@
           </a:lstStyle>
           <a:p>
             <a:r>
-              <a:rPr lang="en-US"/>
+              <a:rPr lang="en-US" smtClean="0"/>
               <a:t>Click to edit Master title style</a:t>
             </a:r>
+            <a:endParaRPr lang="en-US"/>
           </a:p>
         </p:txBody>
       </p:sp>
@@ -1526,7 +1523,7 @@
           <a:p>
             <a:pPr lvl="0"/>
             <a:r>
-              <a:rPr lang="en-US"/>
+              <a:rPr lang="en-US" smtClean="0"/>
               <a:t>Click to edit Master text styles</a:t>
             </a:r>
           </a:p>
@@ -1582,37 +1579,38 @@
           <a:p>
             <a:pPr lvl="0"/>
             <a:r>
-              <a:rPr lang="en-US"/>
+              <a:rPr lang="en-US" smtClean="0"/>
               <a:t>Click to edit Master text styles</a:t>
             </a:r>
           </a:p>
           <a:p>
             <a:pPr lvl="1"/>
             <a:r>
-              <a:rPr lang="en-US"/>
+              <a:rPr lang="en-US" smtClean="0"/>
               <a:t>Second level</a:t>
             </a:r>
           </a:p>
           <a:p>
             <a:pPr lvl="2"/>
             <a:r>
-              <a:rPr lang="en-US"/>
+              <a:rPr lang="en-US" smtClean="0"/>
               <a:t>Third level</a:t>
             </a:r>
           </a:p>
           <a:p>
             <a:pPr lvl="3"/>
             <a:r>
-              <a:rPr lang="en-US"/>
+              <a:rPr lang="en-US" smtClean="0"/>
               <a:t>Fourth level</a:t>
             </a:r>
           </a:p>
           <a:p>
             <a:pPr lvl="4"/>
             <a:r>
-              <a:rPr lang="en-US"/>
+              <a:rPr lang="en-US" smtClean="0"/>
               <a:t>Fifth level</a:t>
             </a:r>
+            <a:endParaRPr lang="en-US"/>
           </a:p>
         </p:txBody>
       </p:sp>
@@ -1675,7 +1673,7 @@
           <a:p>
             <a:pPr lvl="0"/>
             <a:r>
-              <a:rPr lang="en-US"/>
+              <a:rPr lang="en-US" smtClean="0"/>
               <a:t>Click to edit Master text styles</a:t>
             </a:r>
           </a:p>
@@ -1731,37 +1729,38 @@
           <a:p>
             <a:pPr lvl="0"/>
             <a:r>
-              <a:rPr lang="en-US"/>
+              <a:rPr lang="en-US" smtClean="0"/>
               <a:t>Click to edit Master text styles</a:t>
             </a:r>
           </a:p>
           <a:p>
             <a:pPr lvl="1"/>
             <a:r>
-              <a:rPr lang="en-US"/>
+              <a:rPr lang="en-US" smtClean="0"/>
               <a:t>Second level</a:t>
             </a:r>
           </a:p>
           <a:p>
             <a:pPr lvl="2"/>
             <a:r>
-              <a:rPr lang="en-US"/>
+              <a:rPr lang="en-US" smtClean="0"/>
               <a:t>Third level</a:t>
             </a:r>
           </a:p>
           <a:p>
             <a:pPr lvl="3"/>
             <a:r>
-              <a:rPr lang="en-US"/>
+              <a:rPr lang="en-US" smtClean="0"/>
               <a:t>Fourth level</a:t>
             </a:r>
           </a:p>
           <a:p>
             <a:pPr lvl="4"/>
             <a:r>
-              <a:rPr lang="en-US"/>
+              <a:rPr lang="en-US" smtClean="0"/>
               <a:t>Fifth level</a:t>
             </a:r>
+            <a:endParaRPr lang="en-US"/>
           </a:p>
         </p:txBody>
       </p:sp>
@@ -1782,7 +1781,7 @@
           <a:p>
             <a:fld id="{5BCAD085-E8A6-8845-BD4E-CB4CCA059FC4}" type="datetimeFigureOut">
               <a:rPr lang="en-US" smtClean="0"/>
-              <a:t>10/13/26</a:t>
+              <a:t>1/27/13</a:t>
             </a:fld>
             <a:endParaRPr lang="en-US"/>
           </a:p>
@@ -1876,9 +1875,10 @@
           <a:lstStyle/>
           <a:p>
             <a:r>
-              <a:rPr lang="en-US"/>
+              <a:rPr lang="en-US" smtClean="0"/>
               <a:t>Click to edit Master title style</a:t>
             </a:r>
+            <a:endParaRPr lang="en-US"/>
           </a:p>
         </p:txBody>
       </p:sp>
@@ -1899,7 +1899,7 @@
           <a:p>
             <a:fld id="{5BCAD085-E8A6-8845-BD4E-CB4CCA059FC4}" type="datetimeFigureOut">
               <a:rPr lang="en-US" smtClean="0"/>
-              <a:t>10/13/26</a:t>
+              <a:t>1/27/13</a:t>
             </a:fld>
             <a:endParaRPr lang="en-US"/>
           </a:p>
@@ -1994,7 +1994,7 @@
           <a:p>
             <a:fld id="{5BCAD085-E8A6-8845-BD4E-CB4CCA059FC4}" type="datetimeFigureOut">
               <a:rPr lang="en-US" smtClean="0"/>
-              <a:t>10/13/26</a:t>
+              <a:t>1/27/13</a:t>
             </a:fld>
             <a:endParaRPr lang="en-US"/>
           </a:p>
@@ -2097,9 +2097,10 @@
           </a:lstStyle>
           <a:p>
             <a:r>
-              <a:rPr lang="en-US"/>
+              <a:rPr lang="en-US" smtClean="0"/>
               <a:t>Click to edit Master title style</a:t>
             </a:r>
+            <a:endParaRPr lang="en-US"/>
           </a:p>
         </p:txBody>
       </p:sp>
@@ -2153,37 +2154,38 @@
           <a:p>
             <a:pPr lvl="0"/>
             <a:r>
-              <a:rPr lang="en-US"/>
+              <a:rPr lang="en-US" smtClean="0"/>
               <a:t>Click to edit Master text styles</a:t>
             </a:r>
           </a:p>
           <a:p>
             <a:pPr lvl="1"/>
             <a:r>
-              <a:rPr lang="en-US"/>
+              <a:rPr lang="en-US" smtClean="0"/>
               <a:t>Second level</a:t>
             </a:r>
           </a:p>
           <a:p>
             <a:pPr lvl="2"/>
             <a:r>
-              <a:rPr lang="en-US"/>
+              <a:rPr lang="en-US" smtClean="0"/>
               <a:t>Third level</a:t>
             </a:r>
           </a:p>
           <a:p>
             <a:pPr lvl="3"/>
             <a:r>
-              <a:rPr lang="en-US"/>
+              <a:rPr lang="en-US" smtClean="0"/>
               <a:t>Fourth level</a:t>
             </a:r>
           </a:p>
           <a:p>
             <a:pPr lvl="4"/>
             <a:r>
-              <a:rPr lang="en-US"/>
+              <a:rPr lang="en-US" smtClean="0"/>
               <a:t>Fifth level</a:t>
             </a:r>
+            <a:endParaRPr lang="en-US"/>
           </a:p>
         </p:txBody>
       </p:sp>
@@ -2246,7 +2248,7 @@
           <a:p>
             <a:pPr lvl="0"/>
             <a:r>
-              <a:rPr lang="en-US"/>
+              <a:rPr lang="en-US" smtClean="0"/>
               <a:t>Click to edit Master text styles</a:t>
             </a:r>
           </a:p>
@@ -2269,7 +2271,7 @@
           <a:p>
             <a:fld id="{5BCAD085-E8A6-8845-BD4E-CB4CCA059FC4}" type="datetimeFigureOut">
               <a:rPr lang="en-US" smtClean="0"/>
-              <a:t>10/13/26</a:t>
+              <a:t>1/27/13</a:t>
             </a:fld>
             <a:endParaRPr lang="en-US"/>
           </a:p>
@@ -2372,9 +2374,10 @@
           </a:lstStyle>
           <a:p>
             <a:r>
-              <a:rPr lang="en-US"/>
+              <a:rPr lang="en-US" smtClean="0"/>
               <a:t>Click to edit Master title style</a:t>
             </a:r>
+            <a:endParaRPr lang="en-US"/>
           </a:p>
         </p:txBody>
       </p:sp>
@@ -2498,7 +2501,7 @@
           <a:p>
             <a:pPr lvl="0"/>
             <a:r>
-              <a:rPr lang="en-US"/>
+              <a:rPr lang="en-US" smtClean="0"/>
               <a:t>Click to edit Master text styles</a:t>
             </a:r>
           </a:p>
@@ -2521,7 +2524,7 @@
           <a:p>
             <a:fld id="{5BCAD085-E8A6-8845-BD4E-CB4CCA059FC4}" type="datetimeFigureOut">
               <a:rPr lang="en-US" smtClean="0"/>
-              <a:t>10/13/26</a:t>
+              <a:t>1/27/13</a:t>
             </a:fld>
             <a:endParaRPr lang="en-US"/>
           </a:p>
@@ -2630,9 +2633,10 @@
           <a:lstStyle/>
           <a:p>
             <a:r>
-              <a:rPr lang="en-US"/>
+              <a:rPr lang="en-US" smtClean="0"/>
               <a:t>Click to edit Master title style</a:t>
             </a:r>
+            <a:endParaRPr lang="en-US"/>
           </a:p>
         </p:txBody>
       </p:sp>
@@ -2663,37 +2667,38 @@
           <a:p>
             <a:pPr lvl="0"/>
             <a:r>
-              <a:rPr lang="en-US"/>
+              <a:rPr lang="en-US" smtClean="0"/>
               <a:t>Click to edit Master text styles</a:t>
             </a:r>
           </a:p>
           <a:p>
             <a:pPr lvl="1"/>
             <a:r>
-              <a:rPr lang="en-US"/>
+              <a:rPr lang="en-US" smtClean="0"/>
               <a:t>Second level</a:t>
             </a:r>
           </a:p>
           <a:p>
             <a:pPr lvl="2"/>
             <a:r>
-              <a:rPr lang="en-US"/>
+              <a:rPr lang="en-US" smtClean="0"/>
               <a:t>Third level</a:t>
             </a:r>
           </a:p>
           <a:p>
             <a:pPr lvl="3"/>
             <a:r>
-              <a:rPr lang="en-US"/>
+              <a:rPr lang="en-US" smtClean="0"/>
               <a:t>Fourth level</a:t>
             </a:r>
           </a:p>
           <a:p>
             <a:pPr lvl="4"/>
             <a:r>
-              <a:rPr lang="en-US"/>
+              <a:rPr lang="en-US" smtClean="0"/>
               <a:t>Fifth level</a:t>
             </a:r>
+            <a:endParaRPr lang="en-US"/>
           </a:p>
         </p:txBody>
       </p:sp>
@@ -2732,7 +2737,7 @@
           <a:p>
             <a:fld id="{5BCAD085-E8A6-8845-BD4E-CB4CCA059FC4}" type="datetimeFigureOut">
               <a:rPr lang="en-US" smtClean="0"/>
-              <a:t>10/13/26</a:t>
+              <a:t>1/27/13</a:t>
             </a:fld>
             <a:endParaRPr lang="en-US"/>
           </a:p>
@@ -3091,7 +3096,7 @@
 </file>
 
 <file path=ppt/slides/slide1.xml><?xml version="1.0" encoding="utf-8"?>
-<p:sld xmlns:a="http://schemas.openxmlformats.org/drawingml/2006/main" xmlns:r="http://schemas.openxmlformats.org/officeDocument/2006/relationships" xmlns:p="http://schemas.openxmlformats.org/presentationml/2006/main">
+<p:sld xmlns:a="http://schemas.openxmlformats.org/drawingml/2006/main" xmlns:p="http://schemas.openxmlformats.org/presentationml/2006/main" xmlns:r="http://schemas.openxmlformats.org/officeDocument/2006/relationships">
   <p:cSld>
     <p:spTree>
       <p:nvGrpSpPr>
@@ -3099,14 +3104,7 @@
         <p:cNvGrpSpPr/>
         <p:nvPr/>
       </p:nvGrpSpPr>
-      <p:grpSpPr>
-        <a:xfrm>
-          <a:off x="0" y="0"/>
-          <a:ext cx="0" cy="0"/>
-          <a:chOff x="0" y="0"/>
-          <a:chExt cx="0" cy="0"/>
-        </a:xfrm>
-      </p:grpSpPr>
+      <p:grpSpPr/>
       <p:sp>
         <p:nvSpPr>
           <p:cNvPr id="2" name="Rectangle 1"/>
@@ -3147,7 +3145,6 @@
           <a:lstStyle/>
           <a:p>
             <a:pPr algn="ctr"/>
-            <a:endParaRPr/>
           </a:p>
         </p:txBody>
       </p:sp>
@@ -3191,7 +3188,6 @@
           <a:lstStyle/>
           <a:p>
             <a:pPr algn="ctr"/>
-            <a:endParaRPr/>
           </a:p>
         </p:txBody>
       </p:sp>
@@ -3235,7 +3231,6 @@
           <a:lstStyle/>
           <a:p>
             <a:pPr algn="ctr"/>
-            <a:endParaRPr/>
           </a:p>
         </p:txBody>
       </p:sp>
@@ -3415,7 +3410,6 @@
           <a:lstStyle/>
           <a:p>
             <a:pPr algn="ctr"/>
-            <a:endParaRPr/>
           </a:p>
         </p:txBody>
       </p:sp>
@@ -3493,7 +3487,6 @@
           <a:lstStyle/>
           <a:p>
             <a:pPr algn="ctr"/>
-            <a:endParaRPr/>
           </a:p>
         </p:txBody>
       </p:sp>
@@ -3571,7 +3564,6 @@
           <a:lstStyle/>
           <a:p>
             <a:pPr algn="ctr"/>
-            <a:endParaRPr/>
           </a:p>
         </p:txBody>
       </p:sp>
@@ -3719,17 +3711,19 @@
         </p:nvSpPr>
         <p:spPr>
           <a:xfrm>
-            <a:off x="0" y="6510528"/>
-            <a:ext cx="12188952" cy="347472"/>
-          </a:xfrm>
-          <a:prstGeom prst="rect">
-            <a:avLst/>
-          </a:prstGeom>
-          <a:solidFill>
-            <a:srgbClr val="1E3A8A"/>
-          </a:solidFill>
-          <a:ln>
-            <a:noFill/>
+            <a:off x="640080" y="5870448"/>
+            <a:ext cx="6217920" cy="384048"/>
+          </a:xfrm>
+          <a:prstGeom prst="rect">
+            <a:avLst/>
+          </a:prstGeom>
+          <a:solidFill>
+            <a:srgbClr val="162B6B"/>
+          </a:solidFill>
+          <a:ln w="10160">
+            <a:solidFill>
+              <a:srgbClr val="F59E0B"/>
+            </a:solidFill>
           </a:ln>
         </p:spPr>
         <p:style>
@@ -3751,13 +3745,90 @@
           <a:lstStyle/>
           <a:p>
             <a:pPr algn="ctr"/>
-            <a:endParaRPr/>
           </a:p>
         </p:txBody>
       </p:sp>
       <p:sp>
         <p:nvSpPr>
           <p:cNvPr id="19" name="TextBox 18"/>
+          <p:cNvSpPr txBox="1"/>
+          <p:nvPr/>
+        </p:nvSpPr>
+        <p:spPr>
+          <a:xfrm>
+            <a:off x="777240" y="5916168"/>
+            <a:ext cx="5943600" cy="292608"/>
+          </a:xfrm>
+          <a:prstGeom prst="rect">
+            <a:avLst/>
+          </a:prstGeom>
+          <a:noFill/>
+        </p:spPr>
+        <p:txBody>
+          <a:bodyPr wrap="square">
+            <a:spAutoFit/>
+          </a:bodyPr>
+          <a:lstStyle/>
+          <a:p>
+            <a:pPr algn="l"/>
+            <a:r>
+              <a:rPr sz="1100" b="1" i="0">
+                <a:solidFill>
+                  <a:srgbClr val="BFDBFF"/>
+                </a:solidFill>
+                <a:hlinkClick r:id="rId2"/>
+              </a:rPr>
+              <a:t>GitHub: github.com/rahimeblc/rahime_nacak_assignment4_presentation</a:t>
+            </a:r>
+          </a:p>
+        </p:txBody>
+      </p:sp>
+      <p:sp>
+        <p:nvSpPr>
+          <p:cNvPr id="20" name="Rectangle 19"/>
+          <p:cNvSpPr/>
+          <p:nvPr/>
+        </p:nvSpPr>
+        <p:spPr>
+          <a:xfrm>
+            <a:off x="0" y="6510528"/>
+            <a:ext cx="12188952" cy="347472"/>
+          </a:xfrm>
+          <a:prstGeom prst="rect">
+            <a:avLst/>
+          </a:prstGeom>
+          <a:solidFill>
+            <a:srgbClr val="1E3A8A"/>
+          </a:solidFill>
+          <a:ln>
+            <a:noFill/>
+          </a:ln>
+        </p:spPr>
+        <p:style>
+          <a:lnRef idx="1">
+            <a:schemeClr val="accent1"/>
+          </a:lnRef>
+          <a:fillRef idx="3">
+            <a:schemeClr val="accent1"/>
+          </a:fillRef>
+          <a:effectRef idx="2">
+            <a:schemeClr val="accent1"/>
+          </a:effectRef>
+          <a:fontRef idx="minor">
+            <a:schemeClr val="lt1"/>
+          </a:fontRef>
+        </p:style>
+        <p:txBody>
+          <a:bodyPr rtlCol="0" anchor="ctr"/>
+          <a:lstStyle/>
+          <a:p>
+            <a:pPr algn="ctr"/>
+          </a:p>
+        </p:txBody>
+      </p:sp>
+      <p:sp>
+        <p:nvSpPr>
+          <p:cNvPr id="21" name="TextBox 20"/>
           <p:cNvSpPr txBox="1"/>
           <p:nvPr/>
         </p:nvSpPr>
@@ -3791,7 +3862,7 @@
       </p:sp>
       <p:sp>
         <p:nvSpPr>
-          <p:cNvPr id="20" name="TextBox 19"/>
+          <p:cNvPr id="22" name="TextBox 21"/>
           <p:cNvSpPr txBox="1"/>
           <p:nvPr/>
         </p:nvSpPr>
@@ -3832,7 +3903,7 @@
 </file>
 
 <file path=ppt/slides/slide10.xml><?xml version="1.0" encoding="utf-8"?>
-<p:sld xmlns:a="http://schemas.openxmlformats.org/drawingml/2006/main" xmlns:r="http://schemas.openxmlformats.org/officeDocument/2006/relationships" xmlns:p="http://schemas.openxmlformats.org/presentationml/2006/main">
+<p:sld xmlns:a="http://schemas.openxmlformats.org/drawingml/2006/main" xmlns:p="http://schemas.openxmlformats.org/presentationml/2006/main" xmlns:r="http://schemas.openxmlformats.org/officeDocument/2006/relationships">
   <p:cSld>
     <p:spTree>
       <p:nvGrpSpPr>
@@ -3840,14 +3911,7 @@
         <p:cNvGrpSpPr/>
         <p:nvPr/>
       </p:nvGrpSpPr>
-      <p:grpSpPr>
-        <a:xfrm>
-          <a:off x="0" y="0"/>
-          <a:ext cx="0" cy="0"/>
-          <a:chOff x="0" y="0"/>
-          <a:chExt cx="0" cy="0"/>
-        </a:xfrm>
-      </p:grpSpPr>
+      <p:grpSpPr/>
       <p:sp>
         <p:nvSpPr>
           <p:cNvPr id="2" name="Rectangle 1"/>
@@ -3888,7 +3952,6 @@
           <a:lstStyle/>
           <a:p>
             <a:pPr algn="ctr"/>
-            <a:endParaRPr/>
           </a:p>
         </p:txBody>
       </p:sp>
@@ -3932,7 +3995,6 @@
           <a:lstStyle/>
           <a:p>
             <a:pPr algn="ctr"/>
-            <a:endParaRPr/>
           </a:p>
         </p:txBody>
       </p:sp>
@@ -3976,7 +4038,6 @@
           <a:lstStyle/>
           <a:p>
             <a:pPr algn="ctr"/>
-            <a:endParaRPr/>
           </a:p>
         </p:txBody>
       </p:sp>
@@ -4020,7 +4081,6 @@
           <a:lstStyle/>
           <a:p>
             <a:pPr algn="ctr"/>
-            <a:endParaRPr/>
           </a:p>
         </p:txBody>
       </p:sp>
@@ -4166,7 +4226,6 @@
           <a:lstStyle/>
           <a:p>
             <a:pPr algn="ctr"/>
-            <a:endParaRPr/>
           </a:p>
         </p:txBody>
       </p:sp>
@@ -4244,7 +4303,6 @@
           <a:lstStyle/>
           <a:p>
             <a:pPr algn="ctr"/>
-            <a:endParaRPr/>
           </a:p>
         </p:txBody>
       </p:sp>
@@ -4322,7 +4380,6 @@
           <a:lstStyle/>
           <a:p>
             <a:pPr algn="ctr"/>
-            <a:endParaRPr/>
           </a:p>
         </p:txBody>
       </p:sp>
@@ -4400,7 +4457,6 @@
           <a:lstStyle/>
           <a:p>
             <a:pPr algn="ctr"/>
-            <a:endParaRPr/>
           </a:p>
         </p:txBody>
       </p:sp>
@@ -4478,7 +4534,6 @@
           <a:lstStyle/>
           <a:p>
             <a:pPr algn="ctr"/>
-            <a:endParaRPr/>
           </a:p>
         </p:txBody>
       </p:sp>
@@ -4559,7 +4614,7 @@
 </file>
 
 <file path=ppt/slides/slide11.xml><?xml version="1.0" encoding="utf-8"?>
-<p:sld xmlns:a="http://schemas.openxmlformats.org/drawingml/2006/main" xmlns:r="http://schemas.openxmlformats.org/officeDocument/2006/relationships" xmlns:p="http://schemas.openxmlformats.org/presentationml/2006/main">
+<p:sld xmlns:a="http://schemas.openxmlformats.org/drawingml/2006/main" xmlns:p="http://schemas.openxmlformats.org/presentationml/2006/main" xmlns:r="http://schemas.openxmlformats.org/officeDocument/2006/relationships">
   <p:cSld>
     <p:spTree>
       <p:nvGrpSpPr>
@@ -4567,14 +4622,7 @@
         <p:cNvGrpSpPr/>
         <p:nvPr/>
       </p:nvGrpSpPr>
-      <p:grpSpPr>
-        <a:xfrm>
-          <a:off x="0" y="0"/>
-          <a:ext cx="0" cy="0"/>
-          <a:chOff x="0" y="0"/>
-          <a:chExt cx="0" cy="0"/>
-        </a:xfrm>
-      </p:grpSpPr>
+      <p:grpSpPr/>
       <p:sp>
         <p:nvSpPr>
           <p:cNvPr id="2" name="Rectangle 1"/>
@@ -4615,7 +4663,6 @@
           <a:lstStyle/>
           <a:p>
             <a:pPr algn="ctr"/>
-            <a:endParaRPr/>
           </a:p>
         </p:txBody>
       </p:sp>
@@ -4659,7 +4706,6 @@
           <a:lstStyle/>
           <a:p>
             <a:pPr algn="ctr"/>
-            <a:endParaRPr/>
           </a:p>
         </p:txBody>
       </p:sp>
@@ -4703,7 +4749,6 @@
           <a:lstStyle/>
           <a:p>
             <a:pPr algn="ctr"/>
-            <a:endParaRPr/>
           </a:p>
         </p:txBody>
       </p:sp>
@@ -4815,7 +4860,6 @@
           <a:lstStyle/>
           <a:p>
             <a:pPr algn="ctr"/>
-            <a:endParaRPr/>
           </a:p>
         </p:txBody>
       </p:sp>
@@ -4927,7 +4971,6 @@
           <a:lstStyle/>
           <a:p>
             <a:pPr algn="ctr"/>
-            <a:endParaRPr/>
           </a:p>
         </p:txBody>
       </p:sp>
@@ -4973,7 +5016,6 @@
           <a:lstStyle/>
           <a:p>
             <a:pPr algn="ctr"/>
-            <a:endParaRPr/>
           </a:p>
         </p:txBody>
       </p:sp>
@@ -5017,7 +5059,6 @@
           <a:lstStyle/>
           <a:p>
             <a:pPr algn="ctr"/>
-            <a:endParaRPr/>
           </a:p>
         </p:txBody>
       </p:sp>
@@ -5097,7 +5138,6 @@
           <a:lstStyle/>
           <a:p>
             <a:pPr algn="ctr"/>
-            <a:endParaRPr/>
           </a:p>
         </p:txBody>
       </p:sp>
@@ -5141,7 +5181,6 @@
           <a:lstStyle/>
           <a:p>
             <a:pPr algn="ctr"/>
-            <a:endParaRPr/>
           </a:p>
         </p:txBody>
       </p:sp>
@@ -5255,7 +5294,6 @@
           <a:lstStyle/>
           <a:p>
             <a:pPr algn="ctr"/>
-            <a:endParaRPr/>
           </a:p>
         </p:txBody>
       </p:sp>
@@ -5299,7 +5337,6 @@
           <a:lstStyle/>
           <a:p>
             <a:pPr algn="ctr"/>
-            <a:endParaRPr/>
           </a:p>
         </p:txBody>
       </p:sp>
@@ -5413,7 +5450,6 @@
           <a:lstStyle/>
           <a:p>
             <a:pPr algn="ctr"/>
-            <a:endParaRPr/>
           </a:p>
         </p:txBody>
       </p:sp>
@@ -5457,7 +5493,6 @@
           <a:lstStyle/>
           <a:p>
             <a:pPr algn="ctr"/>
-            <a:endParaRPr/>
           </a:p>
         </p:txBody>
       </p:sp>
@@ -5571,7 +5606,6 @@
           <a:lstStyle/>
           <a:p>
             <a:pPr algn="ctr"/>
-            <a:endParaRPr/>
           </a:p>
         </p:txBody>
       </p:sp>
@@ -5615,7 +5649,6 @@
           <a:lstStyle/>
           <a:p>
             <a:pPr algn="ctr"/>
-            <a:endParaRPr/>
           </a:p>
         </p:txBody>
       </p:sp>
@@ -5729,7 +5762,6 @@
           <a:lstStyle/>
           <a:p>
             <a:pPr algn="ctr"/>
-            <a:endParaRPr/>
           </a:p>
         </p:txBody>
       </p:sp>
@@ -5773,7 +5805,6 @@
           <a:lstStyle/>
           <a:p>
             <a:pPr algn="ctr"/>
-            <a:endParaRPr/>
           </a:p>
         </p:txBody>
       </p:sp>
@@ -5885,7 +5916,6 @@
           <a:lstStyle/>
           <a:p>
             <a:pPr algn="ctr"/>
-            <a:endParaRPr/>
           </a:p>
         </p:txBody>
       </p:sp>
@@ -5966,7 +5996,6 @@
           <a:lstStyle/>
           <a:p>
             <a:pPr algn="ctr"/>
-            <a:endParaRPr/>
           </a:p>
         </p:txBody>
       </p:sp>
@@ -6010,7 +6039,6 @@
           <a:lstStyle/>
           <a:p>
             <a:pPr algn="ctr"/>
-            <a:endParaRPr/>
           </a:p>
         </p:txBody>
       </p:sp>
@@ -6081,7 +6109,7 @@
 </file>
 
 <file path=ppt/slides/slide12.xml><?xml version="1.0" encoding="utf-8"?>
-<p:sld xmlns:a="http://schemas.openxmlformats.org/drawingml/2006/main" xmlns:r="http://schemas.openxmlformats.org/officeDocument/2006/relationships" xmlns:p="http://schemas.openxmlformats.org/presentationml/2006/main">
+<p:sld xmlns:a="http://schemas.openxmlformats.org/drawingml/2006/main" xmlns:p="http://schemas.openxmlformats.org/presentationml/2006/main" xmlns:r="http://schemas.openxmlformats.org/officeDocument/2006/relationships">
   <p:cSld>
     <p:spTree>
       <p:nvGrpSpPr>
@@ -6089,14 +6117,7 @@
         <p:cNvGrpSpPr/>
         <p:nvPr/>
       </p:nvGrpSpPr>
-      <p:grpSpPr>
-        <a:xfrm>
-          <a:off x="0" y="0"/>
-          <a:ext cx="0" cy="0"/>
-          <a:chOff x="0" y="0"/>
-          <a:chExt cx="0" cy="0"/>
-        </a:xfrm>
-      </p:grpSpPr>
+      <p:grpSpPr/>
       <p:sp>
         <p:nvSpPr>
           <p:cNvPr id="2" name="Rectangle 1"/>
@@ -6137,7 +6158,6 @@
           <a:lstStyle/>
           <a:p>
             <a:pPr algn="ctr"/>
-            <a:endParaRPr/>
           </a:p>
         </p:txBody>
       </p:sp>
@@ -6181,7 +6201,6 @@
           <a:lstStyle/>
           <a:p>
             <a:pPr algn="ctr"/>
-            <a:endParaRPr/>
           </a:p>
         </p:txBody>
       </p:sp>
@@ -6225,7 +6244,6 @@
           <a:lstStyle/>
           <a:p>
             <a:pPr algn="ctr"/>
-            <a:endParaRPr/>
           </a:p>
         </p:txBody>
       </p:sp>
@@ -6337,7 +6355,6 @@
           <a:lstStyle/>
           <a:p>
             <a:pPr algn="ctr"/>
-            <a:endParaRPr/>
           </a:p>
         </p:txBody>
       </p:sp>
@@ -6449,7 +6466,6 @@
           <a:lstStyle/>
           <a:p>
             <a:pPr algn="ctr"/>
-            <a:endParaRPr/>
           </a:p>
         </p:txBody>
       </p:sp>
@@ -6495,7 +6511,6 @@
           <a:lstStyle/>
           <a:p>
             <a:pPr algn="ctr"/>
-            <a:endParaRPr/>
           </a:p>
         </p:txBody>
       </p:sp>
@@ -6539,7 +6554,6 @@
           <a:lstStyle/>
           <a:p>
             <a:pPr algn="ctr"/>
-            <a:endParaRPr/>
           </a:p>
         </p:txBody>
       </p:sp>
@@ -6805,7 +6819,6 @@
           <a:lstStyle/>
           <a:p>
             <a:pPr algn="ctr"/>
-            <a:endParaRPr/>
           </a:p>
         </p:txBody>
       </p:sp>
@@ -6886,7 +6899,6 @@
           <a:lstStyle/>
           <a:p>
             <a:pPr algn="ctr"/>
-            <a:endParaRPr/>
           </a:p>
         </p:txBody>
       </p:sp>
@@ -6930,7 +6942,6 @@
           <a:lstStyle/>
           <a:p>
             <a:pPr algn="ctr"/>
-            <a:endParaRPr/>
           </a:p>
         </p:txBody>
       </p:sp>
@@ -7001,7 +7012,7 @@
 </file>
 
 <file path=ppt/slides/slide13.xml><?xml version="1.0" encoding="utf-8"?>
-<p:sld xmlns:a="http://schemas.openxmlformats.org/drawingml/2006/main" xmlns:r="http://schemas.openxmlformats.org/officeDocument/2006/relationships" xmlns:p="http://schemas.openxmlformats.org/presentationml/2006/main">
+<p:sld xmlns:a="http://schemas.openxmlformats.org/drawingml/2006/main" xmlns:p="http://schemas.openxmlformats.org/presentationml/2006/main" xmlns:r="http://schemas.openxmlformats.org/officeDocument/2006/relationships">
   <p:cSld>
     <p:spTree>
       <p:nvGrpSpPr>
@@ -7009,14 +7020,7 @@
         <p:cNvGrpSpPr/>
         <p:nvPr/>
       </p:nvGrpSpPr>
-      <p:grpSpPr>
-        <a:xfrm>
-          <a:off x="0" y="0"/>
-          <a:ext cx="0" cy="0"/>
-          <a:chOff x="0" y="0"/>
-          <a:chExt cx="0" cy="0"/>
-        </a:xfrm>
-      </p:grpSpPr>
+      <p:grpSpPr/>
       <p:sp>
         <p:nvSpPr>
           <p:cNvPr id="2" name="Rectangle 1"/>
@@ -7057,7 +7061,6 @@
           <a:lstStyle/>
           <a:p>
             <a:pPr algn="ctr"/>
-            <a:endParaRPr/>
           </a:p>
         </p:txBody>
       </p:sp>
@@ -7101,7 +7104,6 @@
           <a:lstStyle/>
           <a:p>
             <a:pPr algn="ctr"/>
-            <a:endParaRPr/>
           </a:p>
         </p:txBody>
       </p:sp>
@@ -7145,7 +7147,6 @@
           <a:lstStyle/>
           <a:p>
             <a:pPr algn="ctr"/>
-            <a:endParaRPr/>
           </a:p>
         </p:txBody>
       </p:sp>
@@ -7257,7 +7258,6 @@
           <a:lstStyle/>
           <a:p>
             <a:pPr algn="ctr"/>
-            <a:endParaRPr/>
           </a:p>
         </p:txBody>
       </p:sp>
@@ -7369,7 +7369,6 @@
           <a:lstStyle/>
           <a:p>
             <a:pPr algn="ctr"/>
-            <a:endParaRPr/>
           </a:p>
         </p:txBody>
       </p:sp>
@@ -7415,7 +7414,6 @@
           <a:lstStyle/>
           <a:p>
             <a:pPr algn="ctr"/>
-            <a:endParaRPr/>
           </a:p>
         </p:txBody>
       </p:sp>
@@ -7459,7 +7457,6 @@
           <a:lstStyle/>
           <a:p>
             <a:pPr algn="ctr"/>
-            <a:endParaRPr/>
           </a:p>
         </p:txBody>
       </p:sp>
@@ -7710,7 +7707,6 @@
           <a:lstStyle/>
           <a:p>
             <a:pPr algn="ctr"/>
-            <a:endParaRPr/>
           </a:p>
         </p:txBody>
       </p:sp>
@@ -7791,7 +7787,6 @@
           <a:lstStyle/>
           <a:p>
             <a:pPr algn="ctr"/>
-            <a:endParaRPr/>
           </a:p>
         </p:txBody>
       </p:sp>
@@ -7835,7 +7830,6 @@
           <a:lstStyle/>
           <a:p>
             <a:pPr algn="ctr"/>
-            <a:endParaRPr/>
           </a:p>
         </p:txBody>
       </p:sp>
@@ -7906,7 +7900,7 @@
 </file>
 
 <file path=ppt/slides/slide14.xml><?xml version="1.0" encoding="utf-8"?>
-<p:sld xmlns:a="http://schemas.openxmlformats.org/drawingml/2006/main" xmlns:r="http://schemas.openxmlformats.org/officeDocument/2006/relationships" xmlns:p="http://schemas.openxmlformats.org/presentationml/2006/main">
+<p:sld xmlns:a="http://schemas.openxmlformats.org/drawingml/2006/main" xmlns:p="http://schemas.openxmlformats.org/presentationml/2006/main" xmlns:r="http://schemas.openxmlformats.org/officeDocument/2006/relationships">
   <p:cSld>
     <p:spTree>
       <p:nvGrpSpPr>
@@ -7914,14 +7908,7 @@
         <p:cNvGrpSpPr/>
         <p:nvPr/>
       </p:nvGrpSpPr>
-      <p:grpSpPr>
-        <a:xfrm>
-          <a:off x="0" y="0"/>
-          <a:ext cx="0" cy="0"/>
-          <a:chOff x="0" y="0"/>
-          <a:chExt cx="0" cy="0"/>
-        </a:xfrm>
-      </p:grpSpPr>
+      <p:grpSpPr/>
       <p:sp>
         <p:nvSpPr>
           <p:cNvPr id="2" name="Rectangle 1"/>
@@ -7962,7 +7949,6 @@
           <a:lstStyle/>
           <a:p>
             <a:pPr algn="ctr"/>
-            <a:endParaRPr/>
           </a:p>
         </p:txBody>
       </p:sp>
@@ -8006,7 +7992,6 @@
           <a:lstStyle/>
           <a:p>
             <a:pPr algn="ctr"/>
-            <a:endParaRPr/>
           </a:p>
         </p:txBody>
       </p:sp>
@@ -8050,7 +8035,6 @@
           <a:lstStyle/>
           <a:p>
             <a:pPr algn="ctr"/>
-            <a:endParaRPr/>
           </a:p>
         </p:txBody>
       </p:sp>
@@ -8162,7 +8146,6 @@
           <a:lstStyle/>
           <a:p>
             <a:pPr algn="ctr"/>
-            <a:endParaRPr/>
           </a:p>
         </p:txBody>
       </p:sp>
@@ -8274,7 +8257,6 @@
           <a:lstStyle/>
           <a:p>
             <a:pPr algn="ctr"/>
-            <a:endParaRPr/>
           </a:p>
         </p:txBody>
       </p:sp>
@@ -8318,7 +8300,6 @@
           <a:lstStyle/>
           <a:p>
             <a:pPr algn="ctr"/>
-            <a:endParaRPr/>
           </a:p>
         </p:txBody>
       </p:sp>
@@ -8398,7 +8379,6 @@
           <a:lstStyle/>
           <a:p>
             <a:pPr algn="ctr"/>
-            <a:endParaRPr/>
           </a:p>
         </p:txBody>
       </p:sp>
@@ -8442,7 +8422,6 @@
           <a:lstStyle/>
           <a:p>
             <a:pPr algn="ctr"/>
-            <a:endParaRPr/>
           </a:p>
         </p:txBody>
       </p:sp>
@@ -8522,7 +8501,6 @@
           <a:lstStyle/>
           <a:p>
             <a:pPr algn="ctr"/>
-            <a:endParaRPr/>
           </a:p>
         </p:txBody>
       </p:sp>
@@ -8637,7 +8615,6 @@
           <a:lstStyle/>
           <a:p>
             <a:pPr algn="ctr"/>
-            <a:endParaRPr/>
           </a:p>
         </p:txBody>
       </p:sp>
@@ -8681,7 +8658,6 @@
           <a:lstStyle/>
           <a:p>
             <a:pPr algn="ctr"/>
-            <a:endParaRPr/>
           </a:p>
         </p:txBody>
       </p:sp>
@@ -8761,7 +8737,6 @@
           <a:lstStyle/>
           <a:p>
             <a:pPr algn="ctr"/>
-            <a:endParaRPr/>
           </a:p>
         </p:txBody>
       </p:sp>
@@ -8876,7 +8851,6 @@
           <a:lstStyle/>
           <a:p>
             <a:pPr algn="ctr"/>
-            <a:endParaRPr/>
           </a:p>
         </p:txBody>
       </p:sp>
@@ -8920,7 +8894,6 @@
           <a:lstStyle/>
           <a:p>
             <a:pPr algn="ctr"/>
-            <a:endParaRPr/>
           </a:p>
         </p:txBody>
       </p:sp>
@@ -9000,7 +8973,6 @@
           <a:lstStyle/>
           <a:p>
             <a:pPr algn="ctr"/>
-            <a:endParaRPr/>
           </a:p>
         </p:txBody>
       </p:sp>
@@ -9115,7 +9087,6 @@
           <a:lstStyle/>
           <a:p>
             <a:pPr algn="ctr"/>
-            <a:endParaRPr/>
           </a:p>
         </p:txBody>
       </p:sp>
@@ -9159,7 +9130,6 @@
           <a:lstStyle/>
           <a:p>
             <a:pPr algn="ctr"/>
-            <a:endParaRPr/>
           </a:p>
         </p:txBody>
       </p:sp>
@@ -9239,7 +9209,6 @@
           <a:lstStyle/>
           <a:p>
             <a:pPr algn="ctr"/>
-            <a:endParaRPr/>
           </a:p>
         </p:txBody>
       </p:sp>
@@ -9352,7 +9321,6 @@
           <a:lstStyle/>
           <a:p>
             <a:pPr algn="ctr"/>
-            <a:endParaRPr/>
           </a:p>
         </p:txBody>
       </p:sp>
@@ -9396,7 +9364,6 @@
           <a:lstStyle/>
           <a:p>
             <a:pPr algn="ctr"/>
-            <a:endParaRPr/>
           </a:p>
         </p:txBody>
       </p:sp>
@@ -9464,7 +9431,8 @@
                 </a:solidFill>
               </a:rPr>
               <a:t># From the project root, launch FastAPI, Streamlit, MLflow, and Grafana in detached mode:
-cd "/Users/BlankUser/Desktop/data mining A3" &amp;&amp; docker compose up -d</a:t>
+cd "/Users/BlankUser/Desktop/data mining A3" &amp;&amp; docker compose up -d
+# Presentation Source: https://github.com/rahimeblc/rahime_nacak_assignment4_presentation</a:t>
             </a:r>
           </a:p>
         </p:txBody>
@@ -9478,7 +9446,7 @@
 </file>
 
 <file path=ppt/slides/slide15.xml><?xml version="1.0" encoding="utf-8"?>
-<p:sld xmlns:a="http://schemas.openxmlformats.org/drawingml/2006/main" xmlns:r="http://schemas.openxmlformats.org/officeDocument/2006/relationships" xmlns:p="http://schemas.openxmlformats.org/presentationml/2006/main">
+<p:sld xmlns:a="http://schemas.openxmlformats.org/drawingml/2006/main" xmlns:p="http://schemas.openxmlformats.org/presentationml/2006/main" xmlns:r="http://schemas.openxmlformats.org/officeDocument/2006/relationships">
   <p:cSld>
     <p:spTree>
       <p:nvGrpSpPr>
@@ -9486,14 +9454,7 @@
         <p:cNvGrpSpPr/>
         <p:nvPr/>
       </p:nvGrpSpPr>
-      <p:grpSpPr>
-        <a:xfrm>
-          <a:off x="0" y="0"/>
-          <a:ext cx="0" cy="0"/>
-          <a:chOff x="0" y="0"/>
-          <a:chExt cx="0" cy="0"/>
-        </a:xfrm>
-      </p:grpSpPr>
+      <p:grpSpPr/>
       <p:sp>
         <p:nvSpPr>
           <p:cNvPr id="2" name="Rectangle 1"/>
@@ -9534,7 +9495,6 @@
           <a:lstStyle/>
           <a:p>
             <a:pPr algn="ctr"/>
-            <a:endParaRPr/>
           </a:p>
         </p:txBody>
       </p:sp>
@@ -9578,7 +9538,6 @@
           <a:lstStyle/>
           <a:p>
             <a:pPr algn="ctr"/>
-            <a:endParaRPr/>
           </a:p>
         </p:txBody>
       </p:sp>
@@ -9622,7 +9581,6 @@
           <a:lstStyle/>
           <a:p>
             <a:pPr algn="ctr"/>
-            <a:endParaRPr/>
           </a:p>
         </p:txBody>
       </p:sp>
@@ -9734,7 +9692,6 @@
           <a:lstStyle/>
           <a:p>
             <a:pPr algn="ctr"/>
-            <a:endParaRPr/>
           </a:p>
         </p:txBody>
       </p:sp>
@@ -9846,7 +9803,6 @@
           <a:lstStyle/>
           <a:p>
             <a:pPr algn="ctr"/>
-            <a:endParaRPr/>
           </a:p>
         </p:txBody>
       </p:sp>
@@ -9890,7 +9846,6 @@
           <a:lstStyle/>
           <a:p>
             <a:pPr algn="ctr"/>
-            <a:endParaRPr/>
           </a:p>
         </p:txBody>
       </p:sp>
@@ -9934,7 +9889,6 @@
           <a:lstStyle/>
           <a:p>
             <a:pPr algn="ctr"/>
-            <a:endParaRPr/>
           </a:p>
         </p:txBody>
       </p:sp>
@@ -10114,7 +10068,6 @@
           <a:lstStyle/>
           <a:p>
             <a:pPr algn="ctr"/>
-            <a:endParaRPr/>
           </a:p>
         </p:txBody>
       </p:sp>
@@ -10158,7 +10111,6 @@
           <a:lstStyle/>
           <a:p>
             <a:pPr algn="ctr"/>
-            <a:endParaRPr/>
           </a:p>
         </p:txBody>
       </p:sp>
@@ -10338,7 +10290,6 @@
           <a:lstStyle/>
           <a:p>
             <a:pPr algn="ctr"/>
-            <a:endParaRPr/>
           </a:p>
         </p:txBody>
       </p:sp>
@@ -10382,7 +10333,6 @@
           <a:lstStyle/>
           <a:p>
             <a:pPr algn="ctr"/>
-            <a:endParaRPr/>
           </a:p>
         </p:txBody>
       </p:sp>
@@ -10562,7 +10512,6 @@
           <a:lstStyle/>
           <a:p>
             <a:pPr algn="ctr"/>
-            <a:endParaRPr/>
           </a:p>
         </p:txBody>
       </p:sp>
@@ -10606,7 +10555,6 @@
           <a:lstStyle/>
           <a:p>
             <a:pPr algn="ctr"/>
-            <a:endParaRPr/>
           </a:p>
         </p:txBody>
       </p:sp>
@@ -10786,7 +10734,6 @@
           <a:lstStyle/>
           <a:p>
             <a:pPr algn="ctr"/>
-            <a:endParaRPr/>
           </a:p>
         </p:txBody>
       </p:sp>
@@ -10833,7 +10780,7 @@
 </file>
 
 <file path=ppt/slides/slide16.xml><?xml version="1.0" encoding="utf-8"?>
-<p:sld xmlns:a="http://schemas.openxmlformats.org/drawingml/2006/main" xmlns:r="http://schemas.openxmlformats.org/officeDocument/2006/relationships" xmlns:p="http://schemas.openxmlformats.org/presentationml/2006/main">
+<p:sld xmlns:a="http://schemas.openxmlformats.org/drawingml/2006/main" xmlns:p="http://schemas.openxmlformats.org/presentationml/2006/main" xmlns:r="http://schemas.openxmlformats.org/officeDocument/2006/relationships">
   <p:cSld>
     <p:spTree>
       <p:nvGrpSpPr>
@@ -10841,14 +10788,7 @@
         <p:cNvGrpSpPr/>
         <p:nvPr/>
       </p:nvGrpSpPr>
-      <p:grpSpPr>
-        <a:xfrm>
-          <a:off x="0" y="0"/>
-          <a:ext cx="0" cy="0"/>
-          <a:chOff x="0" y="0"/>
-          <a:chExt cx="0" cy="0"/>
-        </a:xfrm>
-      </p:grpSpPr>
+      <p:grpSpPr/>
       <p:sp>
         <p:nvSpPr>
           <p:cNvPr id="2" name="Rectangle 1"/>
@@ -10889,7 +10829,6 @@
           <a:lstStyle/>
           <a:p>
             <a:pPr algn="ctr"/>
-            <a:endParaRPr/>
           </a:p>
         </p:txBody>
       </p:sp>
@@ -10933,7 +10872,6 @@
           <a:lstStyle/>
           <a:p>
             <a:pPr algn="ctr"/>
-            <a:endParaRPr/>
           </a:p>
         </p:txBody>
       </p:sp>
@@ -10977,7 +10915,6 @@
           <a:lstStyle/>
           <a:p>
             <a:pPr algn="ctr"/>
-            <a:endParaRPr/>
           </a:p>
         </p:txBody>
       </p:sp>
@@ -11089,7 +11026,6 @@
           <a:lstStyle/>
           <a:p>
             <a:pPr algn="ctr"/>
-            <a:endParaRPr/>
           </a:p>
         </p:txBody>
       </p:sp>
@@ -11201,7 +11137,6 @@
           <a:lstStyle/>
           <a:p>
             <a:pPr algn="ctr"/>
-            <a:endParaRPr/>
           </a:p>
         </p:txBody>
       </p:sp>
@@ -11245,7 +11180,6 @@
           <a:lstStyle/>
           <a:p>
             <a:pPr algn="ctr"/>
-            <a:endParaRPr/>
           </a:p>
         </p:txBody>
       </p:sp>
@@ -11289,7 +11223,6 @@
           <a:lstStyle/>
           <a:p>
             <a:pPr algn="ctr"/>
-            <a:endParaRPr/>
           </a:p>
         </p:txBody>
       </p:sp>
@@ -11570,7 +11503,6 @@
           <a:lstStyle/>
           <a:p>
             <a:pPr algn="ctr"/>
-            <a:endParaRPr/>
           </a:p>
         </p:txBody>
       </p:sp>
@@ -11614,7 +11546,6 @@
           <a:lstStyle/>
           <a:p>
             <a:pPr algn="ctr"/>
-            <a:endParaRPr/>
           </a:p>
         </p:txBody>
       </p:sp>
@@ -11864,7 +11795,7 @@
 </file>
 
 <file path=ppt/slides/slide17.xml><?xml version="1.0" encoding="utf-8"?>
-<p:sld xmlns:a="http://schemas.openxmlformats.org/drawingml/2006/main" xmlns:r="http://schemas.openxmlformats.org/officeDocument/2006/relationships" xmlns:p="http://schemas.openxmlformats.org/presentationml/2006/main">
+<p:sld xmlns:a="http://schemas.openxmlformats.org/drawingml/2006/main" xmlns:p="http://schemas.openxmlformats.org/presentationml/2006/main" xmlns:r="http://schemas.openxmlformats.org/officeDocument/2006/relationships">
   <p:cSld>
     <p:spTree>
       <p:nvGrpSpPr>
@@ -11872,14 +11803,7 @@
         <p:cNvGrpSpPr/>
         <p:nvPr/>
       </p:nvGrpSpPr>
-      <p:grpSpPr>
-        <a:xfrm>
-          <a:off x="0" y="0"/>
-          <a:ext cx="0" cy="0"/>
-          <a:chOff x="0" y="0"/>
-          <a:chExt cx="0" cy="0"/>
-        </a:xfrm>
-      </p:grpSpPr>
+      <p:grpSpPr/>
       <p:sp>
         <p:nvSpPr>
           <p:cNvPr id="2" name="Rectangle 1"/>
@@ -11920,7 +11844,6 @@
           <a:lstStyle/>
           <a:p>
             <a:pPr algn="ctr"/>
-            <a:endParaRPr/>
           </a:p>
         </p:txBody>
       </p:sp>
@@ -11964,7 +11887,6 @@
           <a:lstStyle/>
           <a:p>
             <a:pPr algn="ctr"/>
-            <a:endParaRPr/>
           </a:p>
         </p:txBody>
       </p:sp>
@@ -12008,7 +11930,6 @@
           <a:lstStyle/>
           <a:p>
             <a:pPr algn="ctr"/>
-            <a:endParaRPr/>
           </a:p>
         </p:txBody>
       </p:sp>
@@ -12120,7 +12041,6 @@
           <a:lstStyle/>
           <a:p>
             <a:pPr algn="ctr"/>
-            <a:endParaRPr/>
           </a:p>
         </p:txBody>
       </p:sp>
@@ -12232,7 +12152,6 @@
           <a:lstStyle/>
           <a:p>
             <a:pPr algn="ctr"/>
-            <a:endParaRPr/>
           </a:p>
         </p:txBody>
       </p:sp>
@@ -12278,7 +12197,6 @@
           <a:lstStyle/>
           <a:p>
             <a:pPr algn="ctr"/>
-            <a:endParaRPr/>
           </a:p>
         </p:txBody>
       </p:sp>
@@ -12322,7 +12240,6 @@
           <a:lstStyle/>
           <a:p>
             <a:pPr algn="ctr"/>
-            <a:endParaRPr/>
           </a:p>
         </p:txBody>
       </p:sp>
@@ -12436,7 +12353,6 @@
           <a:lstStyle/>
           <a:p>
             <a:pPr algn="ctr"/>
-            <a:endParaRPr/>
           </a:p>
         </p:txBody>
       </p:sp>
@@ -12480,7 +12396,6 @@
           <a:lstStyle/>
           <a:p>
             <a:pPr algn="ctr"/>
-            <a:endParaRPr/>
           </a:p>
         </p:txBody>
       </p:sp>
@@ -12558,7 +12473,6 @@
           <a:lstStyle/>
           <a:p>
             <a:pPr algn="ctr"/>
-            <a:endParaRPr/>
           </a:p>
         </p:txBody>
       </p:sp>
@@ -12670,7 +12584,6 @@
           <a:lstStyle/>
           <a:p>
             <a:pPr algn="ctr"/>
-            <a:endParaRPr/>
           </a:p>
         </p:txBody>
       </p:sp>
@@ -12782,7 +12695,6 @@
           <a:lstStyle/>
           <a:p>
             <a:pPr algn="ctr"/>
-            <a:endParaRPr/>
           </a:p>
         </p:txBody>
       </p:sp>
@@ -12894,7 +12806,6 @@
           <a:lstStyle/>
           <a:p>
             <a:pPr algn="ctr"/>
-            <a:endParaRPr/>
           </a:p>
         </p:txBody>
       </p:sp>
@@ -13008,7 +12919,6 @@
           <a:lstStyle/>
           <a:p>
             <a:pPr algn="ctr"/>
-            <a:endParaRPr/>
           </a:p>
         </p:txBody>
       </p:sp>
@@ -13052,7 +12962,6 @@
           <a:lstStyle/>
           <a:p>
             <a:pPr algn="ctr"/>
-            <a:endParaRPr/>
           </a:p>
         </p:txBody>
       </p:sp>
@@ -13130,7 +13039,6 @@
           <a:lstStyle/>
           <a:p>
             <a:pPr algn="ctr"/>
-            <a:endParaRPr/>
           </a:p>
         </p:txBody>
       </p:sp>
@@ -13242,7 +13150,6 @@
           <a:lstStyle/>
           <a:p>
             <a:pPr algn="ctr"/>
-            <a:endParaRPr/>
           </a:p>
         </p:txBody>
       </p:sp>
@@ -13354,7 +13261,6 @@
           <a:lstStyle/>
           <a:p>
             <a:pPr algn="ctr"/>
-            <a:endParaRPr/>
           </a:p>
         </p:txBody>
       </p:sp>
@@ -13466,7 +13372,6 @@
           <a:lstStyle/>
           <a:p>
             <a:pPr algn="ctr"/>
-            <a:endParaRPr/>
           </a:p>
         </p:txBody>
       </p:sp>
@@ -13547,7 +13452,7 @@
 </file>
 
 <file path=ppt/slides/slide18.xml><?xml version="1.0" encoding="utf-8"?>
-<p:sld xmlns:a="http://schemas.openxmlformats.org/drawingml/2006/main" xmlns:r="http://schemas.openxmlformats.org/officeDocument/2006/relationships" xmlns:p="http://schemas.openxmlformats.org/presentationml/2006/main">
+<p:sld xmlns:a="http://schemas.openxmlformats.org/drawingml/2006/main" xmlns:p="http://schemas.openxmlformats.org/presentationml/2006/main" xmlns:r="http://schemas.openxmlformats.org/officeDocument/2006/relationships">
   <p:cSld>
     <p:spTree>
       <p:nvGrpSpPr>
@@ -13555,14 +13460,7 @@
         <p:cNvGrpSpPr/>
         <p:nvPr/>
       </p:nvGrpSpPr>
-      <p:grpSpPr>
-        <a:xfrm>
-          <a:off x="0" y="0"/>
-          <a:ext cx="0" cy="0"/>
-          <a:chOff x="0" y="0"/>
-          <a:chExt cx="0" cy="0"/>
-        </a:xfrm>
-      </p:grpSpPr>
+      <p:grpSpPr/>
       <p:sp>
         <p:nvSpPr>
           <p:cNvPr id="2" name="Rectangle 1"/>
@@ -13603,7 +13501,6 @@
           <a:lstStyle/>
           <a:p>
             <a:pPr algn="ctr"/>
-            <a:endParaRPr/>
           </a:p>
         </p:txBody>
       </p:sp>
@@ -13647,7 +13544,6 @@
           <a:lstStyle/>
           <a:p>
             <a:pPr algn="ctr"/>
-            <a:endParaRPr/>
           </a:p>
         </p:txBody>
       </p:sp>
@@ -13691,7 +13587,6 @@
           <a:lstStyle/>
           <a:p>
             <a:pPr algn="ctr"/>
-            <a:endParaRPr/>
           </a:p>
         </p:txBody>
       </p:sp>
@@ -13837,7 +13732,6 @@
           <a:lstStyle/>
           <a:p>
             <a:pPr algn="ctr"/>
-            <a:endParaRPr/>
           </a:p>
         </p:txBody>
       </p:sp>
@@ -13915,7 +13809,6 @@
           <a:lstStyle/>
           <a:p>
             <a:pPr algn="ctr"/>
-            <a:endParaRPr/>
           </a:p>
         </p:txBody>
       </p:sp>
@@ -13993,7 +13886,6 @@
           <a:lstStyle/>
           <a:p>
             <a:pPr algn="ctr"/>
-            <a:endParaRPr/>
           </a:p>
         </p:txBody>
       </p:sp>
@@ -14073,8 +13965,8 @@
         </p:nvSpPr>
         <p:spPr>
           <a:xfrm>
-            <a:off x="914400" y="5468112"/>
-            <a:ext cx="10058400" cy="411480"/>
+            <a:off x="914400" y="5413248"/>
+            <a:ext cx="10058400" cy="365760"/>
           </a:xfrm>
           <a:prstGeom prst="rect">
             <a:avLst/>
@@ -14107,23 +13999,58 @@
         </p:nvSpPr>
         <p:spPr>
           <a:xfrm>
-            <a:off x="914400" y="5925312"/>
-            <a:ext cx="10058400" cy="365760"/>
-          </a:xfrm>
-          <a:prstGeom prst="rect">
-            <a:avLst/>
-          </a:prstGeom>
-          <a:noFill/>
-        </p:spPr>
-        <p:txBody>
-          <a:bodyPr wrap="square">
-            <a:spAutoFit/>
-          </a:bodyPr>
-          <a:lstStyle/>
-          <a:p>
-            <a:pPr algn="ctr"/>
-            <a:r>
-              <a:rPr sz="1300" b="0" i="1">
+            <a:off x="914400" y="5779008"/>
+            <a:ext cx="10058400" cy="347472"/>
+          </a:xfrm>
+          <a:prstGeom prst="rect">
+            <a:avLst/>
+          </a:prstGeom>
+          <a:noFill/>
+        </p:spPr>
+        <p:txBody>
+          <a:bodyPr wrap="square">
+            <a:spAutoFit/>
+          </a:bodyPr>
+          <a:lstStyle/>
+          <a:p>
+            <a:pPr algn="ctr"/>
+            <a:r>
+              <a:rPr sz="1300" b="1" i="0">
+                <a:solidFill>
+                  <a:srgbClr val="F59E0B"/>
+                </a:solidFill>
+                <a:hlinkClick r:id="rId2"/>
+              </a:rPr>
+              <a:t>GitHub Repository: https://github.com/rahimeblc/rahime_nacak_assignment4_presentation</a:t>
+            </a:r>
+          </a:p>
+        </p:txBody>
+      </p:sp>
+      <p:sp>
+        <p:nvSpPr>
+          <p:cNvPr id="17" name="TextBox 16"/>
+          <p:cNvSpPr txBox="1"/>
+          <p:nvPr/>
+        </p:nvSpPr>
+        <p:spPr>
+          <a:xfrm>
+            <a:off x="914400" y="6144768"/>
+            <a:ext cx="10058400" cy="320040"/>
+          </a:xfrm>
+          <a:prstGeom prst="rect">
+            <a:avLst/>
+          </a:prstGeom>
+          <a:noFill/>
+        </p:spPr>
+        <p:txBody>
+          <a:bodyPr wrap="square">
+            <a:spAutoFit/>
+          </a:bodyPr>
+          <a:lstStyle/>
+          <a:p>
+            <a:pPr algn="ctr"/>
+            <a:r>
+              <a:rPr sz="1200" b="0" i="1">
                 <a:solidFill>
                   <a:srgbClr val="93C5FD"/>
                 </a:solidFill>
@@ -14135,7 +14062,7 @@
       </p:sp>
       <p:sp>
         <p:nvSpPr>
-          <p:cNvPr id="17" name="Rectangle 16"/>
+          <p:cNvPr id="18" name="Rectangle 17"/>
           <p:cNvSpPr/>
           <p:nvPr/>
         </p:nvSpPr>
@@ -14173,13 +14100,12 @@
           <a:lstStyle/>
           <a:p>
             <a:pPr algn="ctr"/>
-            <a:endParaRPr/>
-          </a:p>
-        </p:txBody>
-      </p:sp>
-      <p:sp>
-        <p:nvSpPr>
-          <p:cNvPr id="18" name="TextBox 17"/>
+          </a:p>
+        </p:txBody>
+      </p:sp>
+      <p:sp>
+        <p:nvSpPr>
+          <p:cNvPr id="19" name="TextBox 18"/>
           <p:cNvSpPr txBox="1"/>
           <p:nvPr/>
         </p:nvSpPr>
@@ -14213,7 +14139,7 @@
       </p:sp>
       <p:sp>
         <p:nvSpPr>
-          <p:cNvPr id="19" name="TextBox 18"/>
+          <p:cNvPr id="20" name="TextBox 19"/>
           <p:cNvSpPr txBox="1"/>
           <p:nvPr/>
         </p:nvSpPr>
@@ -14254,7 +14180,7 @@
 </file>
 
 <file path=ppt/slides/slide2.xml><?xml version="1.0" encoding="utf-8"?>
-<p:sld xmlns:a="http://schemas.openxmlformats.org/drawingml/2006/main" xmlns:r="http://schemas.openxmlformats.org/officeDocument/2006/relationships" xmlns:p="http://schemas.openxmlformats.org/presentationml/2006/main">
+<p:sld xmlns:a="http://schemas.openxmlformats.org/drawingml/2006/main" xmlns:p="http://schemas.openxmlformats.org/presentationml/2006/main" xmlns:r="http://schemas.openxmlformats.org/officeDocument/2006/relationships">
   <p:cSld>
     <p:spTree>
       <p:nvGrpSpPr>
@@ -14262,14 +14188,7 @@
         <p:cNvGrpSpPr/>
         <p:nvPr/>
       </p:nvGrpSpPr>
-      <p:grpSpPr>
-        <a:xfrm>
-          <a:off x="0" y="0"/>
-          <a:ext cx="0" cy="0"/>
-          <a:chOff x="0" y="0"/>
-          <a:chExt cx="0" cy="0"/>
-        </a:xfrm>
-      </p:grpSpPr>
+      <p:grpSpPr/>
       <p:sp>
         <p:nvSpPr>
           <p:cNvPr id="2" name="Rectangle 1"/>
@@ -14310,7 +14229,6 @@
           <a:lstStyle/>
           <a:p>
             <a:pPr algn="ctr"/>
-            <a:endParaRPr/>
           </a:p>
         </p:txBody>
       </p:sp>
@@ -14354,7 +14272,6 @@
           <a:lstStyle/>
           <a:p>
             <a:pPr algn="ctr"/>
-            <a:endParaRPr/>
           </a:p>
         </p:txBody>
       </p:sp>
@@ -14398,7 +14315,6 @@
           <a:lstStyle/>
           <a:p>
             <a:pPr algn="ctr"/>
-            <a:endParaRPr/>
           </a:p>
         </p:txBody>
       </p:sp>
@@ -14442,7 +14358,6 @@
           <a:lstStyle/>
           <a:p>
             <a:pPr algn="ctr"/>
-            <a:endParaRPr/>
           </a:p>
         </p:txBody>
       </p:sp>
@@ -14588,7 +14503,6 @@
           <a:lstStyle/>
           <a:p>
             <a:pPr algn="ctr"/>
-            <a:endParaRPr/>
           </a:p>
         </p:txBody>
       </p:sp>
@@ -14666,7 +14580,6 @@
           <a:lstStyle/>
           <a:p>
             <a:pPr algn="ctr"/>
-            <a:endParaRPr/>
           </a:p>
         </p:txBody>
       </p:sp>
@@ -14744,7 +14657,6 @@
           <a:lstStyle/>
           <a:p>
             <a:pPr algn="ctr"/>
-            <a:endParaRPr/>
           </a:p>
         </p:txBody>
       </p:sp>
@@ -14822,7 +14734,6 @@
           <a:lstStyle/>
           <a:p>
             <a:pPr algn="ctr"/>
-            <a:endParaRPr/>
           </a:p>
         </p:txBody>
       </p:sp>
@@ -14900,7 +14811,6 @@
           <a:lstStyle/>
           <a:p>
             <a:pPr algn="ctr"/>
-            <a:endParaRPr/>
           </a:p>
         </p:txBody>
       </p:sp>
@@ -14981,7 +14891,7 @@
 </file>
 
 <file path=ppt/slides/slide3.xml><?xml version="1.0" encoding="utf-8"?>
-<p:sld xmlns:a="http://schemas.openxmlformats.org/drawingml/2006/main" xmlns:r="http://schemas.openxmlformats.org/officeDocument/2006/relationships" xmlns:p="http://schemas.openxmlformats.org/presentationml/2006/main">
+<p:sld xmlns:a="http://schemas.openxmlformats.org/drawingml/2006/main" xmlns:p="http://schemas.openxmlformats.org/presentationml/2006/main" xmlns:r="http://schemas.openxmlformats.org/officeDocument/2006/relationships">
   <p:cSld>
     <p:spTree>
       <p:nvGrpSpPr>
@@ -14989,14 +14899,7 @@
         <p:cNvGrpSpPr/>
         <p:nvPr/>
       </p:nvGrpSpPr>
-      <p:grpSpPr>
-        <a:xfrm>
-          <a:off x="0" y="0"/>
-          <a:ext cx="0" cy="0"/>
-          <a:chOff x="0" y="0"/>
-          <a:chExt cx="0" cy="0"/>
-        </a:xfrm>
-      </p:grpSpPr>
+      <p:grpSpPr/>
       <p:sp>
         <p:nvSpPr>
           <p:cNvPr id="2" name="Rectangle 1"/>
@@ -15037,7 +14940,6 @@
           <a:lstStyle/>
           <a:p>
             <a:pPr algn="ctr"/>
-            <a:endParaRPr/>
           </a:p>
         </p:txBody>
       </p:sp>
@@ -15081,7 +14983,6 @@
           <a:lstStyle/>
           <a:p>
             <a:pPr algn="ctr"/>
-            <a:endParaRPr/>
           </a:p>
         </p:txBody>
       </p:sp>
@@ -15125,7 +15026,6 @@
           <a:lstStyle/>
           <a:p>
             <a:pPr algn="ctr"/>
-            <a:endParaRPr/>
           </a:p>
         </p:txBody>
       </p:sp>
@@ -15237,7 +15137,6 @@
           <a:lstStyle/>
           <a:p>
             <a:pPr algn="ctr"/>
-            <a:endParaRPr/>
           </a:p>
         </p:txBody>
       </p:sp>
@@ -15349,7 +15248,6 @@
           <a:lstStyle/>
           <a:p>
             <a:pPr algn="ctr"/>
-            <a:endParaRPr/>
           </a:p>
         </p:txBody>
       </p:sp>
@@ -15393,7 +15291,6 @@
           <a:lstStyle/>
           <a:p>
             <a:pPr algn="ctr"/>
-            <a:endParaRPr/>
           </a:p>
         </p:txBody>
       </p:sp>
@@ -15437,7 +15334,6 @@
           <a:lstStyle/>
           <a:p>
             <a:pPr algn="ctr"/>
-            <a:endParaRPr/>
           </a:p>
         </p:txBody>
       </p:sp>
@@ -15658,7 +15554,6 @@
           <a:lstStyle/>
           <a:p>
             <a:pPr algn="ctr"/>
-            <a:endParaRPr/>
           </a:p>
         </p:txBody>
       </p:sp>
@@ -15702,7 +15597,6 @@
           <a:lstStyle/>
           <a:p>
             <a:pPr algn="ctr"/>
-            <a:endParaRPr/>
           </a:p>
         </p:txBody>
       </p:sp>
@@ -15923,7 +15817,6 @@
           <a:lstStyle/>
           <a:p>
             <a:pPr algn="ctr"/>
-            <a:endParaRPr/>
           </a:p>
         </p:txBody>
       </p:sp>
@@ -16035,7 +15928,6 @@
           <a:lstStyle/>
           <a:p>
             <a:pPr algn="ctr"/>
-            <a:endParaRPr/>
           </a:p>
         </p:txBody>
       </p:sp>
@@ -16147,7 +16039,6 @@
           <a:lstStyle/>
           <a:p>
             <a:pPr algn="ctr"/>
-            <a:endParaRPr/>
           </a:p>
         </p:txBody>
       </p:sp>
@@ -16259,7 +16150,6 @@
           <a:lstStyle/>
           <a:p>
             <a:pPr algn="ctr"/>
-            <a:endParaRPr/>
           </a:p>
         </p:txBody>
       </p:sp>
@@ -16340,7 +16230,7 @@
 </file>
 
 <file path=ppt/slides/slide4.xml><?xml version="1.0" encoding="utf-8"?>
-<p:sld xmlns:a="http://schemas.openxmlformats.org/drawingml/2006/main" xmlns:r="http://schemas.openxmlformats.org/officeDocument/2006/relationships" xmlns:p="http://schemas.openxmlformats.org/presentationml/2006/main">
+<p:sld xmlns:a="http://schemas.openxmlformats.org/drawingml/2006/main" xmlns:p="http://schemas.openxmlformats.org/presentationml/2006/main" xmlns:r="http://schemas.openxmlformats.org/officeDocument/2006/relationships">
   <p:cSld>
     <p:spTree>
       <p:nvGrpSpPr>
@@ -16348,14 +16238,7 @@
         <p:cNvGrpSpPr/>
         <p:nvPr/>
       </p:nvGrpSpPr>
-      <p:grpSpPr>
-        <a:xfrm>
-          <a:off x="0" y="0"/>
-          <a:ext cx="0" cy="0"/>
-          <a:chOff x="0" y="0"/>
-          <a:chExt cx="0" cy="0"/>
-        </a:xfrm>
-      </p:grpSpPr>
+      <p:grpSpPr/>
       <p:sp>
         <p:nvSpPr>
           <p:cNvPr id="2" name="Rectangle 1"/>
@@ -16396,7 +16279,6 @@
           <a:lstStyle/>
           <a:p>
             <a:pPr algn="ctr"/>
-            <a:endParaRPr/>
           </a:p>
         </p:txBody>
       </p:sp>
@@ -16440,7 +16322,6 @@
           <a:lstStyle/>
           <a:p>
             <a:pPr algn="ctr"/>
-            <a:endParaRPr/>
           </a:p>
         </p:txBody>
       </p:sp>
@@ -16484,7 +16365,6 @@
           <a:lstStyle/>
           <a:p>
             <a:pPr algn="ctr"/>
-            <a:endParaRPr/>
           </a:p>
         </p:txBody>
       </p:sp>
@@ -16596,7 +16476,6 @@
           <a:lstStyle/>
           <a:p>
             <a:pPr algn="ctr"/>
-            <a:endParaRPr/>
           </a:p>
         </p:txBody>
       </p:sp>
@@ -16708,7 +16587,6 @@
           <a:lstStyle/>
           <a:p>
             <a:pPr algn="ctr"/>
-            <a:endParaRPr/>
           </a:p>
         </p:txBody>
       </p:sp>
@@ -16752,7 +16630,6 @@
           <a:lstStyle/>
           <a:p>
             <a:pPr algn="ctr"/>
-            <a:endParaRPr/>
           </a:p>
         </p:txBody>
       </p:sp>
@@ -16900,7 +16777,6 @@
           <a:lstStyle/>
           <a:p>
             <a:pPr algn="ctr"/>
-            <a:endParaRPr/>
           </a:p>
         </p:txBody>
       </p:sp>
@@ -17048,7 +16924,6 @@
           <a:lstStyle/>
           <a:p>
             <a:pPr algn="ctr"/>
-            <a:endParaRPr/>
           </a:p>
         </p:txBody>
       </p:sp>
@@ -17196,7 +17071,6 @@
           <a:lstStyle/>
           <a:p>
             <a:pPr algn="ctr"/>
-            <a:endParaRPr/>
           </a:p>
         </p:txBody>
       </p:sp>
@@ -17344,7 +17218,6 @@
           <a:lstStyle/>
           <a:p>
             <a:pPr algn="ctr"/>
-            <a:endParaRPr/>
           </a:p>
         </p:txBody>
       </p:sp>
@@ -17492,7 +17365,6 @@
           <a:lstStyle/>
           <a:p>
             <a:pPr algn="ctr"/>
-            <a:endParaRPr/>
           </a:p>
         </p:txBody>
       </p:sp>
@@ -17536,7 +17408,6 @@
           <a:lstStyle/>
           <a:p>
             <a:pPr algn="ctr"/>
-            <a:endParaRPr/>
           </a:p>
         </p:txBody>
       </p:sp>
@@ -17614,7 +17485,6 @@
           <a:lstStyle/>
           <a:p>
             <a:pPr algn="ctr"/>
-            <a:endParaRPr/>
           </a:p>
         </p:txBody>
       </p:sp>
@@ -17692,7 +17562,6 @@
           <a:lstStyle/>
           <a:p>
             <a:pPr algn="ctr"/>
-            <a:endParaRPr/>
           </a:p>
         </p:txBody>
       </p:sp>
@@ -17770,7 +17639,6 @@
           <a:lstStyle/>
           <a:p>
             <a:pPr algn="ctr"/>
-            <a:endParaRPr/>
           </a:p>
         </p:txBody>
       </p:sp>
@@ -17814,7 +17682,6 @@
           <a:lstStyle/>
           <a:p>
             <a:pPr algn="ctr"/>
-            <a:endParaRPr/>
           </a:p>
         </p:txBody>
       </p:sp>
@@ -17858,7 +17725,6 @@
           <a:lstStyle/>
           <a:p>
             <a:pPr algn="ctr"/>
-            <a:endParaRPr/>
           </a:p>
         </p:txBody>
       </p:sp>
@@ -18004,7 +17870,6 @@
           <a:lstStyle/>
           <a:p>
             <a:pPr algn="ctr"/>
-            <a:endParaRPr/>
           </a:p>
         </p:txBody>
       </p:sp>
@@ -18048,7 +17913,6 @@
           <a:lstStyle/>
           <a:p>
             <a:pPr algn="ctr"/>
-            <a:endParaRPr/>
           </a:p>
         </p:txBody>
       </p:sp>
@@ -18092,7 +17956,6 @@
           <a:lstStyle/>
           <a:p>
             <a:pPr algn="ctr"/>
-            <a:endParaRPr/>
           </a:p>
         </p:txBody>
       </p:sp>
@@ -18238,7 +18101,6 @@
           <a:lstStyle/>
           <a:p>
             <a:pPr algn="ctr"/>
-            <a:endParaRPr/>
           </a:p>
         </p:txBody>
       </p:sp>
@@ -18282,7 +18144,6 @@
           <a:lstStyle/>
           <a:p>
             <a:pPr algn="ctr"/>
-            <a:endParaRPr/>
           </a:p>
         </p:txBody>
       </p:sp>
@@ -18326,7 +18187,6 @@
           <a:lstStyle/>
           <a:p>
             <a:pPr algn="ctr"/>
-            <a:endParaRPr/>
           </a:p>
         </p:txBody>
       </p:sp>
@@ -18472,7 +18332,6 @@
           <a:lstStyle/>
           <a:p>
             <a:pPr algn="ctr"/>
-            <a:endParaRPr/>
           </a:p>
         </p:txBody>
       </p:sp>
@@ -18516,7 +18375,6 @@
           <a:lstStyle/>
           <a:p>
             <a:pPr algn="ctr"/>
-            <a:endParaRPr/>
           </a:p>
         </p:txBody>
       </p:sp>
@@ -18560,7 +18418,6 @@
           <a:lstStyle/>
           <a:p>
             <a:pPr algn="ctr"/>
-            <a:endParaRPr/>
           </a:p>
         </p:txBody>
       </p:sp>
@@ -18706,7 +18563,6 @@
           <a:lstStyle/>
           <a:p>
             <a:pPr algn="ctr"/>
-            <a:endParaRPr/>
           </a:p>
         </p:txBody>
       </p:sp>
@@ -18750,7 +18606,6 @@
           <a:lstStyle/>
           <a:p>
             <a:pPr algn="ctr"/>
-            <a:endParaRPr/>
           </a:p>
         </p:txBody>
       </p:sp>
@@ -18794,7 +18649,6 @@
           <a:lstStyle/>
           <a:p>
             <a:pPr algn="ctr"/>
-            <a:endParaRPr/>
           </a:p>
         </p:txBody>
       </p:sp>
@@ -18940,7 +18794,6 @@
           <a:lstStyle/>
           <a:p>
             <a:pPr algn="ctr"/>
-            <a:endParaRPr/>
           </a:p>
         </p:txBody>
       </p:sp>
@@ -18984,7 +18837,6 @@
           <a:lstStyle/>
           <a:p>
             <a:pPr algn="ctr"/>
-            <a:endParaRPr/>
           </a:p>
         </p:txBody>
       </p:sp>
@@ -19028,7 +18880,6 @@
           <a:lstStyle/>
           <a:p>
             <a:pPr algn="ctr"/>
-            <a:endParaRPr/>
           </a:p>
         </p:txBody>
       </p:sp>
@@ -19174,7 +19025,6 @@
           <a:lstStyle/>
           <a:p>
             <a:pPr algn="ctr"/>
-            <a:endParaRPr/>
           </a:p>
         </p:txBody>
       </p:sp>
@@ -19218,7 +19068,6 @@
           <a:lstStyle/>
           <a:p>
             <a:pPr algn="ctr"/>
-            <a:endParaRPr/>
           </a:p>
         </p:txBody>
       </p:sp>
@@ -19262,7 +19111,6 @@
           <a:lstStyle/>
           <a:p>
             <a:pPr algn="ctr"/>
-            <a:endParaRPr/>
           </a:p>
         </p:txBody>
       </p:sp>
@@ -19377,7 +19225,7 @@
 </file>
 
 <file path=ppt/slides/slide5.xml><?xml version="1.0" encoding="utf-8"?>
-<p:sld xmlns:a="http://schemas.openxmlformats.org/drawingml/2006/main" xmlns:r="http://schemas.openxmlformats.org/officeDocument/2006/relationships" xmlns:p="http://schemas.openxmlformats.org/presentationml/2006/main">
+<p:sld xmlns:a="http://schemas.openxmlformats.org/drawingml/2006/main" xmlns:p="http://schemas.openxmlformats.org/presentationml/2006/main" xmlns:r="http://schemas.openxmlformats.org/officeDocument/2006/relationships">
   <p:cSld>
     <p:spTree>
       <p:nvGrpSpPr>
@@ -19385,14 +19233,7 @@
         <p:cNvGrpSpPr/>
         <p:nvPr/>
       </p:nvGrpSpPr>
-      <p:grpSpPr>
-        <a:xfrm>
-          <a:off x="0" y="0"/>
-          <a:ext cx="0" cy="0"/>
-          <a:chOff x="0" y="0"/>
-          <a:chExt cx="0" cy="0"/>
-        </a:xfrm>
-      </p:grpSpPr>
+      <p:grpSpPr/>
       <p:sp>
         <p:nvSpPr>
           <p:cNvPr id="2" name="Rectangle 1"/>
@@ -19433,7 +19274,6 @@
           <a:lstStyle/>
           <a:p>
             <a:pPr algn="ctr"/>
-            <a:endParaRPr/>
           </a:p>
         </p:txBody>
       </p:sp>
@@ -19477,7 +19317,6 @@
           <a:lstStyle/>
           <a:p>
             <a:pPr algn="ctr"/>
-            <a:endParaRPr/>
           </a:p>
         </p:txBody>
       </p:sp>
@@ -19521,7 +19360,6 @@
           <a:lstStyle/>
           <a:p>
             <a:pPr algn="ctr"/>
-            <a:endParaRPr/>
           </a:p>
         </p:txBody>
       </p:sp>
@@ -19633,7 +19471,6 @@
           <a:lstStyle/>
           <a:p>
             <a:pPr algn="ctr"/>
-            <a:endParaRPr/>
           </a:p>
         </p:txBody>
       </p:sp>
@@ -19745,7 +19582,6 @@
           <a:lstStyle/>
           <a:p>
             <a:pPr algn="ctr"/>
-            <a:endParaRPr/>
           </a:p>
         </p:txBody>
       </p:sp>
@@ -19789,7 +19625,6 @@
           <a:lstStyle/>
           <a:p>
             <a:pPr algn="ctr"/>
-            <a:endParaRPr/>
           </a:p>
         </p:txBody>
       </p:sp>
@@ -19935,7 +19770,6 @@
           <a:lstStyle/>
           <a:p>
             <a:pPr algn="ctr"/>
-            <a:endParaRPr/>
           </a:p>
         </p:txBody>
       </p:sp>
@@ -20081,7 +19915,6 @@
           <a:lstStyle/>
           <a:p>
             <a:pPr algn="ctr"/>
-            <a:endParaRPr/>
           </a:p>
         </p:txBody>
       </p:sp>
@@ -20229,7 +20062,6 @@
           <a:lstStyle/>
           <a:p>
             <a:pPr algn="ctr"/>
-            <a:endParaRPr/>
           </a:p>
         </p:txBody>
       </p:sp>
@@ -20273,7 +20105,6 @@
           <a:lstStyle/>
           <a:p>
             <a:pPr algn="ctr"/>
-            <a:endParaRPr/>
           </a:p>
         </p:txBody>
       </p:sp>
@@ -20351,7 +20182,6 @@
           <a:lstStyle/>
           <a:p>
             <a:pPr algn="ctr"/>
-            <a:endParaRPr/>
           </a:p>
         </p:txBody>
       </p:sp>
@@ -20497,7 +20327,6 @@
           <a:lstStyle/>
           <a:p>
             <a:pPr algn="ctr"/>
-            <a:endParaRPr/>
           </a:p>
         </p:txBody>
       </p:sp>
@@ -20643,7 +20472,6 @@
           <a:lstStyle/>
           <a:p>
             <a:pPr algn="ctr"/>
-            <a:endParaRPr/>
           </a:p>
         </p:txBody>
       </p:sp>
@@ -20789,7 +20617,6 @@
           <a:lstStyle/>
           <a:p>
             <a:pPr algn="ctr"/>
-            <a:endParaRPr/>
           </a:p>
         </p:txBody>
       </p:sp>
@@ -20935,7 +20762,6 @@
           <a:lstStyle/>
           <a:p>
             <a:pPr algn="ctr"/>
-            <a:endParaRPr/>
           </a:p>
         </p:txBody>
       </p:sp>
@@ -21083,7 +20909,6 @@
           <a:lstStyle/>
           <a:p>
             <a:pPr algn="ctr"/>
-            <a:endParaRPr/>
           </a:p>
         </p:txBody>
       </p:sp>
@@ -21120,7 +20945,7 @@
 </file>
 
 <file path=ppt/slides/slide6.xml><?xml version="1.0" encoding="utf-8"?>
-<p:sld xmlns:a="http://schemas.openxmlformats.org/drawingml/2006/main" xmlns:r="http://schemas.openxmlformats.org/officeDocument/2006/relationships" xmlns:p="http://schemas.openxmlformats.org/presentationml/2006/main">
+<p:sld xmlns:a="http://schemas.openxmlformats.org/drawingml/2006/main" xmlns:p="http://schemas.openxmlformats.org/presentationml/2006/main" xmlns:r="http://schemas.openxmlformats.org/officeDocument/2006/relationships">
   <p:cSld>
     <p:spTree>
       <p:nvGrpSpPr>
@@ -21128,14 +20953,7 @@
         <p:cNvGrpSpPr/>
         <p:nvPr/>
       </p:nvGrpSpPr>
-      <p:grpSpPr>
-        <a:xfrm>
-          <a:off x="0" y="0"/>
-          <a:ext cx="0" cy="0"/>
-          <a:chOff x="0" y="0"/>
-          <a:chExt cx="0" cy="0"/>
-        </a:xfrm>
-      </p:grpSpPr>
+      <p:grpSpPr/>
       <p:sp>
         <p:nvSpPr>
           <p:cNvPr id="2" name="Rectangle 1"/>
@@ -21176,7 +20994,6 @@
           <a:lstStyle/>
           <a:p>
             <a:pPr algn="ctr"/>
-            <a:endParaRPr/>
           </a:p>
         </p:txBody>
       </p:sp>
@@ -21220,7 +21037,6 @@
           <a:lstStyle/>
           <a:p>
             <a:pPr algn="ctr"/>
-            <a:endParaRPr/>
           </a:p>
         </p:txBody>
       </p:sp>
@@ -21264,7 +21080,6 @@
           <a:lstStyle/>
           <a:p>
             <a:pPr algn="ctr"/>
-            <a:endParaRPr/>
           </a:p>
         </p:txBody>
       </p:sp>
@@ -21376,7 +21191,6 @@
           <a:lstStyle/>
           <a:p>
             <a:pPr algn="ctr"/>
-            <a:endParaRPr/>
           </a:p>
         </p:txBody>
       </p:sp>
@@ -21488,7 +21302,6 @@
           <a:lstStyle/>
           <a:p>
             <a:pPr algn="ctr"/>
-            <a:endParaRPr/>
           </a:p>
         </p:txBody>
       </p:sp>
@@ -21534,7 +21347,6 @@
           <a:lstStyle/>
           <a:p>
             <a:pPr algn="ctr"/>
-            <a:endParaRPr/>
           </a:p>
         </p:txBody>
       </p:sp>
@@ -21578,7 +21390,6 @@
           <a:lstStyle/>
           <a:p>
             <a:pPr algn="ctr"/>
-            <a:endParaRPr/>
           </a:p>
         </p:txBody>
       </p:sp>
@@ -21794,7 +21605,6 @@
           <a:lstStyle/>
           <a:p>
             <a:pPr algn="ctr"/>
-            <a:endParaRPr/>
           </a:p>
         </p:txBody>
       </p:sp>
@@ -21908,7 +21718,6 @@
           <a:lstStyle/>
           <a:p>
             <a:pPr algn="ctr"/>
-            <a:endParaRPr/>
           </a:p>
         </p:txBody>
       </p:sp>
@@ -21952,7 +21761,6 @@
           <a:lstStyle/>
           <a:p>
             <a:pPr algn="ctr"/>
-            <a:endParaRPr/>
           </a:p>
         </p:txBody>
       </p:sp>
@@ -22134,7 +21942,6 @@
           <a:lstStyle/>
           <a:p>
             <a:pPr algn="ctr"/>
-            <a:endParaRPr/>
           </a:p>
         </p:txBody>
       </p:sp>
@@ -22230,7 +22037,7 @@
 </file>
 
 <file path=ppt/slides/slide7.xml><?xml version="1.0" encoding="utf-8"?>
-<p:sld xmlns:a="http://schemas.openxmlformats.org/drawingml/2006/main" xmlns:r="http://schemas.openxmlformats.org/officeDocument/2006/relationships" xmlns:p="http://schemas.openxmlformats.org/presentationml/2006/main">
+<p:sld xmlns:a="http://schemas.openxmlformats.org/drawingml/2006/main" xmlns:p="http://schemas.openxmlformats.org/presentationml/2006/main" xmlns:r="http://schemas.openxmlformats.org/officeDocument/2006/relationships">
   <p:cSld>
     <p:spTree>
       <p:nvGrpSpPr>
@@ -22238,14 +22045,7 @@
         <p:cNvGrpSpPr/>
         <p:nvPr/>
       </p:nvGrpSpPr>
-      <p:grpSpPr>
-        <a:xfrm>
-          <a:off x="0" y="0"/>
-          <a:ext cx="0" cy="0"/>
-          <a:chOff x="0" y="0"/>
-          <a:chExt cx="0" cy="0"/>
-        </a:xfrm>
-      </p:grpSpPr>
+      <p:grpSpPr/>
       <p:sp>
         <p:nvSpPr>
           <p:cNvPr id="2" name="Rectangle 1"/>
@@ -22286,7 +22086,6 @@
           <a:lstStyle/>
           <a:p>
             <a:pPr algn="ctr"/>
-            <a:endParaRPr/>
           </a:p>
         </p:txBody>
       </p:sp>
@@ -22330,7 +22129,6 @@
           <a:lstStyle/>
           <a:p>
             <a:pPr algn="ctr"/>
-            <a:endParaRPr/>
           </a:p>
         </p:txBody>
       </p:sp>
@@ -22374,7 +22172,6 @@
           <a:lstStyle/>
           <a:p>
             <a:pPr algn="ctr"/>
-            <a:endParaRPr/>
           </a:p>
         </p:txBody>
       </p:sp>
@@ -22418,7 +22215,6 @@
           <a:lstStyle/>
           <a:p>
             <a:pPr algn="ctr"/>
-            <a:endParaRPr/>
           </a:p>
         </p:txBody>
       </p:sp>
@@ -22564,7 +22360,6 @@
           <a:lstStyle/>
           <a:p>
             <a:pPr algn="ctr"/>
-            <a:endParaRPr/>
           </a:p>
         </p:txBody>
       </p:sp>
@@ -22642,7 +22437,6 @@
           <a:lstStyle/>
           <a:p>
             <a:pPr algn="ctr"/>
-            <a:endParaRPr/>
           </a:p>
         </p:txBody>
       </p:sp>
@@ -22720,7 +22514,6 @@
           <a:lstStyle/>
           <a:p>
             <a:pPr algn="ctr"/>
-            <a:endParaRPr/>
           </a:p>
         </p:txBody>
       </p:sp>
@@ -22801,7 +22594,7 @@
 </file>
 
 <file path=ppt/slides/slide8.xml><?xml version="1.0" encoding="utf-8"?>
-<p:sld xmlns:a="http://schemas.openxmlformats.org/drawingml/2006/main" xmlns:r="http://schemas.openxmlformats.org/officeDocument/2006/relationships" xmlns:p="http://schemas.openxmlformats.org/presentationml/2006/main">
+<p:sld xmlns:a="http://schemas.openxmlformats.org/drawingml/2006/main" xmlns:p="http://schemas.openxmlformats.org/presentationml/2006/main" xmlns:r="http://schemas.openxmlformats.org/officeDocument/2006/relationships">
   <p:cSld>
     <p:spTree>
       <p:nvGrpSpPr>
@@ -22809,14 +22602,7 @@
         <p:cNvGrpSpPr/>
         <p:nvPr/>
       </p:nvGrpSpPr>
-      <p:grpSpPr>
-        <a:xfrm>
-          <a:off x="0" y="0"/>
-          <a:ext cx="0" cy="0"/>
-          <a:chOff x="0" y="0"/>
-          <a:chExt cx="0" cy="0"/>
-        </a:xfrm>
-      </p:grpSpPr>
+      <p:grpSpPr/>
       <p:sp>
         <p:nvSpPr>
           <p:cNvPr id="2" name="Rectangle 1"/>
@@ -22857,7 +22643,6 @@
           <a:lstStyle/>
           <a:p>
             <a:pPr algn="ctr"/>
-            <a:endParaRPr/>
           </a:p>
         </p:txBody>
       </p:sp>
@@ -22901,7 +22686,6 @@
           <a:lstStyle/>
           <a:p>
             <a:pPr algn="ctr"/>
-            <a:endParaRPr/>
           </a:p>
         </p:txBody>
       </p:sp>
@@ -22945,7 +22729,6 @@
           <a:lstStyle/>
           <a:p>
             <a:pPr algn="ctr"/>
-            <a:endParaRPr/>
           </a:p>
         </p:txBody>
       </p:sp>
@@ -23057,7 +22840,6 @@
           <a:lstStyle/>
           <a:p>
             <a:pPr algn="ctr"/>
-            <a:endParaRPr/>
           </a:p>
         </p:txBody>
       </p:sp>
@@ -23169,7 +22951,6 @@
           <a:lstStyle/>
           <a:p>
             <a:pPr algn="ctr"/>
-            <a:endParaRPr/>
           </a:p>
         </p:txBody>
       </p:sp>
@@ -23213,7 +22994,6 @@
           <a:lstStyle/>
           <a:p>
             <a:pPr algn="ctr"/>
-            <a:endParaRPr/>
           </a:p>
         </p:txBody>
       </p:sp>
@@ -23362,7 +23142,6 @@
           <a:lstStyle/>
           <a:p>
             <a:pPr algn="ctr"/>
-            <a:endParaRPr/>
           </a:p>
         </p:txBody>
       </p:sp>
@@ -23748,7 +23527,6 @@
           <a:lstStyle/>
           <a:p>
             <a:pPr algn="ctr"/>
-            <a:endParaRPr/>
           </a:p>
         </p:txBody>
       </p:sp>
@@ -23865,7 +23643,6 @@
           <a:lstStyle/>
           <a:p>
             <a:pPr algn="ctr"/>
-            <a:endParaRPr/>
           </a:p>
         </p:txBody>
       </p:sp>
@@ -23944,7 +23721,6 @@
           <a:lstStyle/>
           <a:p>
             <a:pPr algn="ctr"/>
-            <a:endParaRPr/>
           </a:p>
         </p:txBody>
       </p:sp>
@@ -24092,7 +23868,6 @@
           <a:lstStyle/>
           <a:p>
             <a:pPr algn="ctr"/>
-            <a:endParaRPr/>
           </a:p>
         </p:txBody>
       </p:sp>
@@ -24218,7 +23993,6 @@
           <a:lstStyle/>
           <a:p>
             <a:pPr algn="ctr"/>
-            <a:endParaRPr/>
           </a:p>
         </p:txBody>
       </p:sp>
@@ -24330,7 +24104,6 @@
           <a:lstStyle/>
           <a:p>
             <a:pPr algn="ctr"/>
-            <a:endParaRPr/>
           </a:p>
         </p:txBody>
       </p:sp>
@@ -24442,7 +24215,6 @@
           <a:lstStyle/>
           <a:p>
             <a:pPr algn="ctr"/>
-            <a:endParaRPr/>
           </a:p>
         </p:txBody>
       </p:sp>
@@ -24554,7 +24326,6 @@
           <a:lstStyle/>
           <a:p>
             <a:pPr algn="ctr"/>
-            <a:endParaRPr/>
           </a:p>
         </p:txBody>
       </p:sp>
@@ -24635,7 +24406,7 @@
 </file>
 
 <file path=ppt/slides/slide9.xml><?xml version="1.0" encoding="utf-8"?>
-<p:sld xmlns:a="http://schemas.openxmlformats.org/drawingml/2006/main" xmlns:r="http://schemas.openxmlformats.org/officeDocument/2006/relationships" xmlns:p="http://schemas.openxmlformats.org/presentationml/2006/main">
+<p:sld xmlns:a="http://schemas.openxmlformats.org/drawingml/2006/main" xmlns:p="http://schemas.openxmlformats.org/presentationml/2006/main" xmlns:r="http://schemas.openxmlformats.org/officeDocument/2006/relationships">
   <p:cSld>
     <p:spTree>
       <p:nvGrpSpPr>
@@ -24643,14 +24414,7 @@
         <p:cNvGrpSpPr/>
         <p:nvPr/>
       </p:nvGrpSpPr>
-      <p:grpSpPr>
-        <a:xfrm>
-          <a:off x="0" y="0"/>
-          <a:ext cx="0" cy="0"/>
-          <a:chOff x="0" y="0"/>
-          <a:chExt cx="0" cy="0"/>
-        </a:xfrm>
-      </p:grpSpPr>
+      <p:grpSpPr/>
       <p:sp>
         <p:nvSpPr>
           <p:cNvPr id="2" name="Rectangle 1"/>
@@ -24691,7 +24455,6 @@
           <a:lstStyle/>
           <a:p>
             <a:pPr algn="ctr"/>
-            <a:endParaRPr/>
           </a:p>
         </p:txBody>
       </p:sp>
@@ -24735,7 +24498,6 @@
           <a:lstStyle/>
           <a:p>
             <a:pPr algn="ctr"/>
-            <a:endParaRPr/>
           </a:p>
         </p:txBody>
       </p:sp>
@@ -24779,7 +24541,6 @@
           <a:lstStyle/>
           <a:p>
             <a:pPr algn="ctr"/>
-            <a:endParaRPr/>
           </a:p>
         </p:txBody>
       </p:sp>
@@ -24891,7 +24652,6 @@
           <a:lstStyle/>
           <a:p>
             <a:pPr algn="ctr"/>
-            <a:endParaRPr/>
           </a:p>
         </p:txBody>
       </p:sp>
@@ -25003,7 +24763,6 @@
           <a:lstStyle/>
           <a:p>
             <a:pPr algn="ctr"/>
-            <a:endParaRPr/>
           </a:p>
         </p:txBody>
       </p:sp>
@@ -25049,7 +24808,6 @@
           <a:lstStyle/>
           <a:p>
             <a:pPr algn="ctr"/>
-            <a:endParaRPr/>
           </a:p>
         </p:txBody>
       </p:sp>
@@ -25093,7 +24851,6 @@
           <a:lstStyle/>
           <a:p>
             <a:pPr algn="ctr"/>
-            <a:endParaRPr/>
           </a:p>
         </p:txBody>
       </p:sp>
@@ -25137,7 +24894,6 @@
           <a:lstStyle/>
           <a:p>
             <a:pPr algn="ctr"/>
-            <a:endParaRPr/>
           </a:p>
         </p:txBody>
       </p:sp>
@@ -25181,7 +24937,6 @@
           <a:lstStyle/>
           <a:p>
             <a:pPr algn="ctr"/>
-            <a:endParaRPr/>
           </a:p>
         </p:txBody>
       </p:sp>
@@ -25225,7 +24980,6 @@
           <a:lstStyle/>
           <a:p>
             <a:pPr algn="ctr"/>
-            <a:endParaRPr/>
           </a:p>
         </p:txBody>
       </p:sp>
@@ -25303,7 +25057,6 @@
           <a:lstStyle/>
           <a:p>
             <a:pPr algn="ctr"/>
-            <a:endParaRPr/>
           </a:p>
         </p:txBody>
       </p:sp>
@@ -25347,7 +25100,6 @@
           <a:lstStyle/>
           <a:p>
             <a:pPr algn="ctr"/>
-            <a:endParaRPr/>
           </a:p>
         </p:txBody>
       </p:sp>
@@ -25460,7 +25212,6 @@
           <a:lstStyle/>
           <a:p>
             <a:pPr algn="ctr"/>
-            <a:endParaRPr/>
           </a:p>
         </p:txBody>
       </p:sp>
@@ -25504,7 +25255,6 @@
           <a:lstStyle/>
           <a:p>
             <a:pPr algn="ctr"/>
-            <a:endParaRPr/>
           </a:p>
         </p:txBody>
       </p:sp>
@@ -25551,7 +25301,7 @@
         <p:spPr>
           <a:xfrm>
             <a:off x="1042415" y="4800600"/>
-            <a:ext cx="4892040" cy="246221"/>
+            <a:ext cx="4892040" cy="237744"/>
           </a:xfrm>
           <a:prstGeom prst="rect">
             <a:avLst/>
@@ -25566,14 +25316,11 @@
           <a:p>
             <a:pPr algn="l"/>
             <a:r>
-              <a:rPr sz="1000" b="1" i="0" dirty="0">
-                <a:hlinkClick r:id="rId3">
-                  <a:extLst>
-                    <a:ext uri="{A12FA001-AC4F-418D-AE19-62706E023703}">
-                      <ahyp:hlinkClr xmlns:ahyp="http://schemas.microsoft.com/office/drawing/2018/hyperlinkcolor" val="tx"/>
-                    </a:ext>
-                  </a:extLst>
-                </a:hlinkClick>
+              <a:rPr sz="1000" b="1" i="0">
+                <a:solidFill>
+                  <a:srgbClr val="FFFFFF"/>
+                </a:solidFill>
+                <a:hlinkClick r:id="rId3"/>
               </a:rPr>
               <a:t>/health — Service Readiness &amp; Model Probe</a:t>
             </a:r>
@@ -25620,7 +25367,6 @@
           <a:lstStyle/>
           <a:p>
             <a:pPr algn="ctr"/>
-            <a:endParaRPr/>
           </a:p>
         </p:txBody>
       </p:sp>
@@ -25664,7 +25410,6 @@
           <a:lstStyle/>
           <a:p>
             <a:pPr algn="ctr"/>
-            <a:endParaRPr/>
           </a:p>
         </p:txBody>
       </p:sp>
@@ -25711,7 +25456,7 @@
         <p:spPr>
           <a:xfrm>
             <a:off x="1042415" y="5148072"/>
-            <a:ext cx="4892040" cy="246221"/>
+            <a:ext cx="4892040" cy="237744"/>
           </a:xfrm>
           <a:prstGeom prst="rect">
             <a:avLst/>
@@ -25726,31 +25471,13 @@
           <a:p>
             <a:pPr algn="l"/>
             <a:r>
-              <a:rPr sz="1000" b="1" i="0" dirty="0">
-                <a:hlinkClick r:id="rId4">
-                  <a:extLst>
-                    <a:ext uri="{A12FA001-AC4F-418D-AE19-62706E023703}">
-                      <ahyp:hlinkClr xmlns:ahyp="http://schemas.microsoft.com/office/drawing/2018/hyperlinkcolor" val="tx"/>
-                    </a:ext>
-                  </a:extLst>
-                </a:hlinkClick>
-              </a:rPr>
-              <a:t>/ — Interactive Web UI (HTML / Jinja2</a:t>
-            </a:r>
-            <a:r>
-              <a:rPr sz="1000" b="1" i="0" dirty="0">
-                <a:solidFill>
-                  <a:srgbClr val="0000FF"/>
-                </a:solidFill>
-                <a:hlinkClick r:id="rId4">
-                  <a:extLst>
-                    <a:ext uri="{A12FA001-AC4F-418D-AE19-62706E023703}">
-                      <ahyp:hlinkClr xmlns:ahyp="http://schemas.microsoft.com/office/drawing/2018/hyperlinkcolor" val="tx"/>
-                    </a:ext>
-                  </a:extLst>
-                </a:hlinkClick>
-              </a:rPr>
-              <a:t>)</a:t>
+              <a:rPr sz="1000" b="1" i="0">
+                <a:solidFill>
+                  <a:srgbClr val="FFFFFF"/>
+                </a:solidFill>
+                <a:hlinkClick r:id="rId4"/>
+              </a:rPr>
+              <a:t>/ — Interactive Web UI (HTML / Jinja2)</a:t>
             </a:r>
           </a:p>
         </p:txBody>
@@ -25795,7 +25522,6 @@
           <a:lstStyle/>
           <a:p>
             <a:pPr algn="ctr"/>
-            <a:endParaRPr/>
           </a:p>
         </p:txBody>
       </p:sp>
@@ -25873,7 +25599,6 @@
           <a:lstStyle/>
           <a:p>
             <a:pPr algn="ctr"/>
-            <a:endParaRPr/>
           </a:p>
         </p:txBody>
       </p:sp>
@@ -25953,7 +25678,6 @@
           <a:lstStyle/>
           <a:p>
             <a:pPr algn="ctr"/>
-            <a:endParaRPr/>
           </a:p>
         </p:txBody>
       </p:sp>
@@ -26031,7 +25755,6 @@
           <a:lstStyle/>
           <a:p>
             <a:pPr algn="ctr"/>
-            <a:endParaRPr/>
           </a:p>
         </p:txBody>
       </p:sp>
@@ -26118,7 +25841,6 @@
           <a:lstStyle/>
           <a:p>
             <a:pPr algn="ctr"/>
-            <a:endParaRPr/>
           </a:p>
         </p:txBody>
       </p:sp>
@@ -26200,7 +25922,6 @@
           <a:lstStyle/>
           <a:p>
             <a:pPr algn="ctr"/>
-            <a:endParaRPr/>
           </a:p>
         </p:txBody>
       </p:sp>
@@ -26244,7 +25965,6 @@
           <a:lstStyle/>
           <a:p>
             <a:pPr algn="ctr"/>
-            <a:endParaRPr/>
           </a:p>
         </p:txBody>
       </p:sp>
@@ -26288,7 +26008,6 @@
           <a:lstStyle/>
           <a:p>
             <a:pPr algn="ctr"/>
-            <a:endParaRPr/>
           </a:p>
         </p:txBody>
       </p:sp>
@@ -26332,7 +26051,6 @@
           <a:lstStyle/>
           <a:p>
             <a:pPr algn="ctr"/>
-            <a:endParaRPr/>
           </a:p>
         </p:txBody>
       </p:sp>
@@ -26376,7 +26094,6 @@
           <a:lstStyle/>
           <a:p>
             <a:pPr algn="ctr"/>
-            <a:endParaRPr/>
           </a:p>
         </p:txBody>
       </p:sp>
@@ -26454,7 +26171,6 @@
           <a:lstStyle/>
           <a:p>
             <a:pPr algn="ctr"/>
-            <a:endParaRPr/>
           </a:p>
         </p:txBody>
       </p:sp>
@@ -26567,7 +26283,6 @@
           <a:lstStyle/>
           <a:p>
             <a:pPr algn="ctr"/>
-            <a:endParaRPr/>
           </a:p>
         </p:txBody>
       </p:sp>
@@ -26750,7 +26465,6 @@
           <a:lstStyle/>
           <a:p>
             <a:pPr algn="ctr"/>
-            <a:endParaRPr/>
           </a:p>
         </p:txBody>
       </p:sp>
@@ -26829,7 +26543,6 @@
           <a:lstStyle/>
           <a:p>
             <a:pPr algn="ctr"/>
-            <a:endParaRPr/>
           </a:p>
         </p:txBody>
       </p:sp>
@@ -26910,7 +26623,6 @@
           <a:lstStyle/>
           <a:p>
             <a:pPr algn="ctr"/>
-            <a:endParaRPr/>
           </a:p>
         </p:txBody>
       </p:sp>
@@ -27192,7 +26904,6 @@
           <a:lstStyle/>
           <a:p>
             <a:pPr algn="ctr"/>
-            <a:endParaRPr/>
           </a:p>
         </p:txBody>
       </p:sp>
@@ -27304,7 +27015,6 @@
           <a:lstStyle/>
           <a:p>
             <a:pPr algn="ctr"/>
-            <a:endParaRPr/>
           </a:p>
         </p:txBody>
       </p:sp>
@@ -27416,7 +27126,6 @@
           <a:lstStyle/>
           <a:p>
             <a:pPr algn="ctr"/>
-            <a:endParaRPr/>
           </a:p>
         </p:txBody>
       </p:sp>
@@ -27528,7 +27237,6 @@
           <a:lstStyle/>
           <a:p>
             <a:pPr algn="ctr"/>
-            <a:endParaRPr/>
           </a:p>
         </p:txBody>
       </p:sp>

</xml_diff>